<commit_message>
Add ISSM Business School logo to all five decks
Prepared two versions from the supplied image:
- logo-full.png: trimmed to content, JPEG noise cleaned to pure white, upscaled
  4x for crisp projection. Used top-right on title, section, quote and closing
  slides, sitting on a white plate so the navy and red stay legible on dark
  backgrounds.
- logo-mark.png: crest only, used as a small mark in the content-slide footer
  where the wordmark would be too small to read.

Original WhatsApp file kept as assets/source-whatsapp-original.jpg.
All 119 slides carry exactly one logo; linter clean.
</commit_message>
<xml_diff>
--- a/Unit 5 - Strategy, Innovation and Leadership.pptx
+++ b/Unit 5 - Strategy, Innovation and Leadership.pptx
@@ -3836,7 +3836,77 @@
       </p:sp>
       <p:sp>
         <p:nvSpPr>
-          <p:cNvPr id="7" name="TextBox 6"/>
+          <p:cNvPr id="7" name="logo-plate"/>
+          <p:cNvSpPr/>
+          <p:nvPr/>
+        </p:nvSpPr>
+        <p:spPr>
+          <a:xfrm>
+            <a:off x="9126735" y="539496"/>
+            <a:ext cx="2379159" cy="1152144"/>
+          </a:xfrm>
+          <a:prstGeom prst="roundRect">
+            <a:avLst>
+              <a:gd name="adj" fmla="val 14000"/>
+            </a:avLst>
+          </a:prstGeom>
+          <a:solidFill>
+            <a:srgbClr val="FFFFFF"/>
+          </a:solidFill>
+          <a:ln>
+            <a:noFill/>
+          </a:ln>
+          <a:effectLst/>
+        </p:spPr>
+        <p:style>
+          <a:lnRef idx="1">
+            <a:schemeClr val="accent1"/>
+          </a:lnRef>
+          <a:fillRef idx="3">
+            <a:schemeClr val="accent1"/>
+          </a:fillRef>
+          <a:effectRef idx="2">
+            <a:schemeClr val="accent1"/>
+          </a:effectRef>
+          <a:fontRef idx="minor">
+            <a:schemeClr val="lt1"/>
+          </a:fontRef>
+        </p:style>
+        <p:txBody>
+          <a:bodyPr rtlCol="0" anchor="ctr" wrap="square"/>
+          <a:lstStyle/>
+          <a:p>
+            <a:pPr algn="ctr"/>
+          </a:p>
+        </p:txBody>
+      </p:sp>
+      <p:pic>
+        <p:nvPicPr>
+          <p:cNvPr id="8" name="college-logo" descr="logo-full.png"/>
+          <p:cNvPicPr>
+            <a:picLocks noChangeAspect="1"/>
+          </p:cNvPicPr>
+          <p:nvPr/>
+        </p:nvPicPr>
+        <p:blipFill>
+          <a:blip r:embed="rId2"/>
+          <a:stretch>
+            <a:fillRect/>
+          </a:stretch>
+        </p:blipFill>
+        <p:spPr>
+          <a:xfrm>
+            <a:off x="9245607" y="658368"/>
+            <a:ext cx="2141415" cy="914400"/>
+          </a:xfrm>
+          <a:prstGeom prst="rect">
+            <a:avLst/>
+          </a:prstGeom>
+        </p:spPr>
+      </p:pic>
+      <p:sp>
+        <p:nvSpPr>
+          <p:cNvPr id="9" name="TextBox 8"/>
           <p:cNvSpPr txBox="1"/>
           <p:nvPr/>
         </p:nvSpPr>
@@ -3883,7 +3953,7 @@
       </p:sp>
       <p:sp>
         <p:nvSpPr>
-          <p:cNvPr id="8" name="Rounded Rectangle 7"/>
+          <p:cNvPr id="10" name="Rounded Rectangle 9"/>
           <p:cNvSpPr/>
           <p:nvPr/>
         </p:nvSpPr>
@@ -3950,7 +4020,7 @@
       </p:sp>
       <p:sp>
         <p:nvSpPr>
-          <p:cNvPr id="9" name="TextBox 8"/>
+          <p:cNvPr id="11" name="TextBox 10"/>
           <p:cNvSpPr txBox="1"/>
           <p:nvPr/>
         </p:nvSpPr>
@@ -3997,7 +4067,7 @@
       </p:sp>
       <p:sp>
         <p:nvSpPr>
-          <p:cNvPr id="10" name="Rectangle 9"/>
+          <p:cNvPr id="12" name="Rectangle 11"/>
           <p:cNvSpPr/>
           <p:nvPr/>
         </p:nvSpPr>
@@ -4041,7 +4111,7 @@
       </p:sp>
       <p:sp>
         <p:nvSpPr>
-          <p:cNvPr id="11" name="TextBox 10"/>
+          <p:cNvPr id="13" name="TextBox 12"/>
           <p:cNvSpPr txBox="1"/>
           <p:nvPr/>
         </p:nvSpPr>
@@ -4088,7 +4158,7 @@
       </p:sp>
       <p:sp>
         <p:nvSpPr>
-          <p:cNvPr id="12" name="Rounded Rectangle 11"/>
+          <p:cNvPr id="14" name="Rounded Rectangle 13"/>
           <p:cNvSpPr/>
           <p:nvPr/>
         </p:nvSpPr>
@@ -4155,7 +4225,7 @@
       </p:sp>
       <p:sp>
         <p:nvSpPr>
-          <p:cNvPr id="13" name="Rounded Rectangle 12"/>
+          <p:cNvPr id="15" name="Rounded Rectangle 14"/>
           <p:cNvSpPr/>
           <p:nvPr/>
         </p:nvSpPr>
@@ -4222,7 +4292,7 @@
       </p:sp>
       <p:sp>
         <p:nvSpPr>
-          <p:cNvPr id="14" name="Rounded Rectangle 13"/>
+          <p:cNvPr id="16" name="Rounded Rectangle 15"/>
           <p:cNvSpPr/>
           <p:nvPr/>
         </p:nvSpPr>
@@ -4289,7 +4359,7 @@
       </p:sp>
       <p:sp>
         <p:nvSpPr>
-          <p:cNvPr id="15" name="Rounded Rectangle 14"/>
+          <p:cNvPr id="17" name="Rounded Rectangle 16"/>
           <p:cNvSpPr/>
           <p:nvPr/>
         </p:nvSpPr>
@@ -4356,7 +4426,7 @@
       </p:sp>
       <p:sp>
         <p:nvSpPr>
-          <p:cNvPr id="16" name="Rectangle 15"/>
+          <p:cNvPr id="18" name="Rectangle 17"/>
           <p:cNvSpPr/>
           <p:nvPr/>
         </p:nvSpPr>
@@ -4400,7 +4470,7 @@
       </p:sp>
       <p:sp>
         <p:nvSpPr>
-          <p:cNvPr id="17" name="TextBox 16"/>
+          <p:cNvPr id="19" name="TextBox 18"/>
           <p:cNvSpPr txBox="1"/>
           <p:nvPr/>
         </p:nvSpPr>
@@ -4493,7 +4563,7 @@
       </p:sp>
       <p:sp>
         <p:nvSpPr>
-          <p:cNvPr id="18" name="TextBox 17"/>
+          <p:cNvPr id="20" name="TextBox 19"/>
           <p:cNvSpPr txBox="1"/>
           <p:nvPr/>
         </p:nvSpPr>
@@ -4600,9 +4670,33 @@
           </a:p>
         </p:txBody>
       </p:sp>
-      <p:sp>
-        <p:nvSpPr>
-          <p:cNvPr id="3" name="TextBox 2"/>
+      <p:pic>
+        <p:nvPicPr>
+          <p:cNvPr id="3" name="college-logo" descr="logo-mark.png"/>
+          <p:cNvPicPr>
+            <a:picLocks noChangeAspect="1"/>
+          </p:cNvPicPr>
+          <p:nvPr/>
+        </p:nvPicPr>
+        <p:blipFill>
+          <a:blip r:embed="rId2"/>
+          <a:stretch>
+            <a:fillRect/>
+          </a:stretch>
+        </p:blipFill>
+        <p:spPr>
+          <a:xfrm>
+            <a:off x="11203333" y="6199632"/>
+            <a:ext cx="275129" cy="310896"/>
+          </a:xfrm>
+          <a:prstGeom prst="rect">
+            <a:avLst/>
+          </a:prstGeom>
+        </p:spPr>
+      </p:pic>
+      <p:sp>
+        <p:nvSpPr>
+          <p:cNvPr id="4" name="TextBox 3"/>
           <p:cNvSpPr txBox="1"/>
           <p:nvPr/>
         </p:nvSpPr>
@@ -4671,13 +4765,13 @@
       </p:sp>
       <p:sp>
         <p:nvSpPr>
-          <p:cNvPr id="4" name="TextBox 3"/>
+          <p:cNvPr id="5" name="TextBox 4"/>
           <p:cNvSpPr txBox="1"/>
           <p:nvPr/>
         </p:nvSpPr>
         <p:spPr>
           <a:xfrm>
-            <a:off x="8826703" y="6272784"/>
+            <a:off x="8240677" y="6272784"/>
             <a:ext cx="2651760" cy="219456"/>
           </a:xfrm>
           <a:prstGeom prst="rect">
@@ -4740,7 +4834,7 @@
       </p:sp>
       <p:sp>
         <p:nvSpPr>
-          <p:cNvPr id="5" name="TextBox 4"/>
+          <p:cNvPr id="6" name="TextBox 5"/>
           <p:cNvSpPr txBox="1"/>
           <p:nvPr/>
         </p:nvSpPr>
@@ -4787,7 +4881,7 @@
       </p:sp>
       <p:sp>
         <p:nvSpPr>
-          <p:cNvPr id="6" name="TextBox 5"/>
+          <p:cNvPr id="7" name="TextBox 6"/>
           <p:cNvSpPr txBox="1"/>
           <p:nvPr/>
         </p:nvSpPr>
@@ -4834,7 +4928,7 @@
       </p:sp>
       <p:sp>
         <p:nvSpPr>
-          <p:cNvPr id="7" name="Rectangle 6"/>
+          <p:cNvPr id="8" name="Rectangle 7"/>
           <p:cNvSpPr/>
           <p:nvPr/>
         </p:nvSpPr>
@@ -4878,7 +4972,7 @@
       </p:sp>
       <p:sp>
         <p:nvSpPr>
-          <p:cNvPr id="8" name="TextBox 7"/>
+          <p:cNvPr id="9" name="TextBox 8"/>
           <p:cNvSpPr txBox="1"/>
           <p:nvPr/>
         </p:nvSpPr>
@@ -4925,7 +5019,7 @@
       </p:sp>
       <p:sp>
         <p:nvSpPr>
-          <p:cNvPr id="9" name="Rectangle 8"/>
+          <p:cNvPr id="10" name="Rectangle 9"/>
           <p:cNvSpPr/>
           <p:nvPr/>
         </p:nvSpPr>
@@ -4969,7 +5063,7 @@
       </p:sp>
       <p:sp>
         <p:nvSpPr>
-          <p:cNvPr id="10" name="Rounded Rectangle 9"/>
+          <p:cNvPr id="11" name="Rounded Rectangle 10"/>
           <p:cNvSpPr/>
           <p:nvPr/>
         </p:nvSpPr>
@@ -5015,7 +5109,7 @@
       </p:sp>
       <p:sp>
         <p:nvSpPr>
-          <p:cNvPr id="11" name="TextBox 10"/>
+          <p:cNvPr id="12" name="TextBox 11"/>
           <p:cNvSpPr txBox="1"/>
           <p:nvPr/>
         </p:nvSpPr>
@@ -5062,7 +5156,7 @@
       </p:sp>
       <p:sp>
         <p:nvSpPr>
-          <p:cNvPr id="12" name="Rounded Rectangle 11"/>
+          <p:cNvPr id="13" name="Rounded Rectangle 12"/>
           <p:cNvSpPr/>
           <p:nvPr/>
         </p:nvSpPr>
@@ -5108,7 +5202,7 @@
       </p:sp>
       <p:sp>
         <p:nvSpPr>
-          <p:cNvPr id="13" name="TextBox 12"/>
+          <p:cNvPr id="14" name="TextBox 13"/>
           <p:cNvSpPr txBox="1"/>
           <p:nvPr/>
         </p:nvSpPr>
@@ -5155,7 +5249,7 @@
       </p:sp>
       <p:sp>
         <p:nvSpPr>
-          <p:cNvPr id="14" name="Rounded Rectangle 13"/>
+          <p:cNvPr id="15" name="Rounded Rectangle 14"/>
           <p:cNvSpPr/>
           <p:nvPr/>
         </p:nvSpPr>
@@ -5201,7 +5295,7 @@
       </p:sp>
       <p:sp>
         <p:nvSpPr>
-          <p:cNvPr id="15" name="TextBox 14"/>
+          <p:cNvPr id="16" name="TextBox 15"/>
           <p:cNvSpPr txBox="1"/>
           <p:nvPr/>
         </p:nvSpPr>
@@ -5248,7 +5342,7 @@
       </p:sp>
       <p:sp>
         <p:nvSpPr>
-          <p:cNvPr id="16" name="Rounded Rectangle 15"/>
+          <p:cNvPr id="17" name="Rounded Rectangle 16"/>
           <p:cNvSpPr/>
           <p:nvPr/>
         </p:nvSpPr>
@@ -5294,7 +5388,7 @@
       </p:sp>
       <p:sp>
         <p:nvSpPr>
-          <p:cNvPr id="17" name="TextBox 16"/>
+          <p:cNvPr id="18" name="TextBox 17"/>
           <p:cNvSpPr txBox="1"/>
           <p:nvPr/>
         </p:nvSpPr>
@@ -5341,7 +5435,7 @@
       </p:sp>
       <p:sp>
         <p:nvSpPr>
-          <p:cNvPr id="18" name="Rounded Rectangle 17"/>
+          <p:cNvPr id="19" name="Rounded Rectangle 18"/>
           <p:cNvSpPr/>
           <p:nvPr/>
         </p:nvSpPr>
@@ -5387,7 +5481,7 @@
       </p:sp>
       <p:sp>
         <p:nvSpPr>
-          <p:cNvPr id="19" name="TextBox 18"/>
+          <p:cNvPr id="20" name="TextBox 19"/>
           <p:cNvSpPr txBox="1"/>
           <p:nvPr/>
         </p:nvSpPr>
@@ -5434,7 +5528,7 @@
       </p:sp>
       <p:sp>
         <p:nvSpPr>
-          <p:cNvPr id="20" name="Rounded Rectangle 19"/>
+          <p:cNvPr id="21" name="Rounded Rectangle 20"/>
           <p:cNvSpPr/>
           <p:nvPr/>
         </p:nvSpPr>
@@ -5488,7 +5582,7 @@
       </p:sp>
       <p:sp>
         <p:nvSpPr>
-          <p:cNvPr id="21" name="Rectangle 20"/>
+          <p:cNvPr id="22" name="Rectangle 21"/>
           <p:cNvSpPr/>
           <p:nvPr/>
         </p:nvSpPr>
@@ -5532,7 +5626,7 @@
       </p:sp>
       <p:sp>
         <p:nvSpPr>
-          <p:cNvPr id="22" name="TextBox 21"/>
+          <p:cNvPr id="23" name="TextBox 22"/>
           <p:cNvSpPr txBox="1"/>
           <p:nvPr/>
         </p:nvSpPr>
@@ -5579,7 +5673,7 @@
       </p:sp>
       <p:sp>
         <p:nvSpPr>
-          <p:cNvPr id="23" name="TextBox 22"/>
+          <p:cNvPr id="24" name="TextBox 23"/>
           <p:cNvSpPr txBox="1"/>
           <p:nvPr/>
         </p:nvSpPr>
@@ -5626,7 +5720,7 @@
       </p:sp>
       <p:sp>
         <p:nvSpPr>
-          <p:cNvPr id="24" name="Rounded Rectangle 23"/>
+          <p:cNvPr id="25" name="Rounded Rectangle 24"/>
           <p:cNvSpPr/>
           <p:nvPr/>
         </p:nvSpPr>
@@ -5680,7 +5774,7 @@
       </p:sp>
       <p:sp>
         <p:nvSpPr>
-          <p:cNvPr id="25" name="Rectangle 24"/>
+          <p:cNvPr id="26" name="Rectangle 25"/>
           <p:cNvSpPr/>
           <p:nvPr/>
         </p:nvSpPr>
@@ -5724,7 +5818,7 @@
       </p:sp>
       <p:sp>
         <p:nvSpPr>
-          <p:cNvPr id="26" name="TextBox 25"/>
+          <p:cNvPr id="27" name="TextBox 26"/>
           <p:cNvSpPr txBox="1"/>
           <p:nvPr/>
         </p:nvSpPr>
@@ -5771,7 +5865,7 @@
       </p:sp>
       <p:sp>
         <p:nvSpPr>
-          <p:cNvPr id="27" name="TextBox 26"/>
+          <p:cNvPr id="28" name="TextBox 27"/>
           <p:cNvSpPr txBox="1"/>
           <p:nvPr/>
         </p:nvSpPr>
@@ -5818,7 +5912,7 @@
       </p:sp>
       <p:sp>
         <p:nvSpPr>
-          <p:cNvPr id="28" name="Rounded Rectangle 27"/>
+          <p:cNvPr id="29" name="Rounded Rectangle 28"/>
           <p:cNvSpPr/>
           <p:nvPr/>
         </p:nvSpPr>
@@ -5872,7 +5966,7 @@
       </p:sp>
       <p:sp>
         <p:nvSpPr>
-          <p:cNvPr id="29" name="Rectangle 28"/>
+          <p:cNvPr id="30" name="Rectangle 29"/>
           <p:cNvSpPr/>
           <p:nvPr/>
         </p:nvSpPr>
@@ -5916,7 +6010,7 @@
       </p:sp>
       <p:sp>
         <p:nvSpPr>
-          <p:cNvPr id="30" name="TextBox 29"/>
+          <p:cNvPr id="31" name="TextBox 30"/>
           <p:cNvSpPr txBox="1"/>
           <p:nvPr/>
         </p:nvSpPr>
@@ -5963,7 +6057,7 @@
       </p:sp>
       <p:sp>
         <p:nvSpPr>
-          <p:cNvPr id="31" name="TextBox 30"/>
+          <p:cNvPr id="32" name="TextBox 31"/>
           <p:cNvSpPr txBox="1"/>
           <p:nvPr/>
         </p:nvSpPr>
@@ -6070,9 +6164,33 @@
           </a:p>
         </p:txBody>
       </p:sp>
-      <p:sp>
-        <p:nvSpPr>
-          <p:cNvPr id="3" name="TextBox 2"/>
+      <p:pic>
+        <p:nvPicPr>
+          <p:cNvPr id="3" name="college-logo" descr="logo-mark.png"/>
+          <p:cNvPicPr>
+            <a:picLocks noChangeAspect="1"/>
+          </p:cNvPicPr>
+          <p:nvPr/>
+        </p:nvPicPr>
+        <p:blipFill>
+          <a:blip r:embed="rId2"/>
+          <a:stretch>
+            <a:fillRect/>
+          </a:stretch>
+        </p:blipFill>
+        <p:spPr>
+          <a:xfrm>
+            <a:off x="11203333" y="6199632"/>
+            <a:ext cx="275129" cy="310896"/>
+          </a:xfrm>
+          <a:prstGeom prst="rect">
+            <a:avLst/>
+          </a:prstGeom>
+        </p:spPr>
+      </p:pic>
+      <p:sp>
+        <p:nvSpPr>
+          <p:cNvPr id="4" name="TextBox 3"/>
           <p:cNvSpPr txBox="1"/>
           <p:nvPr/>
         </p:nvSpPr>
@@ -6141,13 +6259,13 @@
       </p:sp>
       <p:sp>
         <p:nvSpPr>
-          <p:cNvPr id="4" name="TextBox 3"/>
+          <p:cNvPr id="5" name="TextBox 4"/>
           <p:cNvSpPr txBox="1"/>
           <p:nvPr/>
         </p:nvSpPr>
         <p:spPr>
           <a:xfrm>
-            <a:off x="8826703" y="6272784"/>
+            <a:off x="8240677" y="6272784"/>
             <a:ext cx="2651760" cy="219456"/>
           </a:xfrm>
           <a:prstGeom prst="rect">
@@ -6210,7 +6328,7 @@
       </p:sp>
       <p:sp>
         <p:nvSpPr>
-          <p:cNvPr id="5" name="TextBox 4"/>
+          <p:cNvPr id="6" name="TextBox 5"/>
           <p:cNvSpPr txBox="1"/>
           <p:nvPr/>
         </p:nvSpPr>
@@ -6257,7 +6375,7 @@
       </p:sp>
       <p:sp>
         <p:nvSpPr>
-          <p:cNvPr id="6" name="TextBox 5"/>
+          <p:cNvPr id="7" name="TextBox 6"/>
           <p:cNvSpPr txBox="1"/>
           <p:nvPr/>
         </p:nvSpPr>
@@ -6304,7 +6422,7 @@
       </p:sp>
       <p:sp>
         <p:nvSpPr>
-          <p:cNvPr id="7" name="Rectangle 6"/>
+          <p:cNvPr id="8" name="Rectangle 7"/>
           <p:cNvSpPr/>
           <p:nvPr/>
         </p:nvSpPr>
@@ -6348,7 +6466,7 @@
       </p:sp>
       <p:graphicFrame>
         <p:nvGraphicFramePr>
-          <p:cNvPr id="8" name="Table 7"/>
+          <p:cNvPr id="9" name="Table 8"/>
           <p:cNvGraphicFramePr>
             <a:graphicFrameLocks noGrp="1"/>
           </p:cNvGraphicFramePr>
@@ -6944,7 +7062,7 @@
       </p:graphicFrame>
       <p:sp>
         <p:nvSpPr>
-          <p:cNvPr id="9" name="Rounded Rectangle 8"/>
+          <p:cNvPr id="10" name="Rounded Rectangle 9"/>
           <p:cNvSpPr/>
           <p:nvPr/>
         </p:nvSpPr>
@@ -7011,7 +7129,7 @@
       </p:sp>
       <p:sp>
         <p:nvSpPr>
-          <p:cNvPr id="10" name="Rectangle 9"/>
+          <p:cNvPr id="11" name="Rectangle 10"/>
           <p:cNvSpPr/>
           <p:nvPr/>
         </p:nvSpPr>
@@ -7115,9 +7233,33 @@
           </a:p>
         </p:txBody>
       </p:sp>
-      <p:sp>
-        <p:nvSpPr>
-          <p:cNvPr id="3" name="TextBox 2"/>
+      <p:pic>
+        <p:nvPicPr>
+          <p:cNvPr id="3" name="college-logo" descr="logo-mark.png"/>
+          <p:cNvPicPr>
+            <a:picLocks noChangeAspect="1"/>
+          </p:cNvPicPr>
+          <p:nvPr/>
+        </p:nvPicPr>
+        <p:blipFill>
+          <a:blip r:embed="rId2"/>
+          <a:stretch>
+            <a:fillRect/>
+          </a:stretch>
+        </p:blipFill>
+        <p:spPr>
+          <a:xfrm>
+            <a:off x="11203333" y="6199632"/>
+            <a:ext cx="275129" cy="310896"/>
+          </a:xfrm>
+          <a:prstGeom prst="rect">
+            <a:avLst/>
+          </a:prstGeom>
+        </p:spPr>
+      </p:pic>
+      <p:sp>
+        <p:nvSpPr>
+          <p:cNvPr id="4" name="TextBox 3"/>
           <p:cNvSpPr txBox="1"/>
           <p:nvPr/>
         </p:nvSpPr>
@@ -7186,13 +7328,13 @@
       </p:sp>
       <p:sp>
         <p:nvSpPr>
-          <p:cNvPr id="4" name="TextBox 3"/>
+          <p:cNvPr id="5" name="TextBox 4"/>
           <p:cNvSpPr txBox="1"/>
           <p:nvPr/>
         </p:nvSpPr>
         <p:spPr>
           <a:xfrm>
-            <a:off x="8826703" y="6272784"/>
+            <a:off x="8240677" y="6272784"/>
             <a:ext cx="2651760" cy="219456"/>
           </a:xfrm>
           <a:prstGeom prst="rect">
@@ -7255,7 +7397,7 @@
       </p:sp>
       <p:sp>
         <p:nvSpPr>
-          <p:cNvPr id="5" name="TextBox 4"/>
+          <p:cNvPr id="6" name="TextBox 5"/>
           <p:cNvSpPr txBox="1"/>
           <p:nvPr/>
         </p:nvSpPr>
@@ -7302,7 +7444,7 @@
       </p:sp>
       <p:sp>
         <p:nvSpPr>
-          <p:cNvPr id="6" name="TextBox 5"/>
+          <p:cNvPr id="7" name="TextBox 6"/>
           <p:cNvSpPr txBox="1"/>
           <p:nvPr/>
         </p:nvSpPr>
@@ -7349,7 +7491,7 @@
       </p:sp>
       <p:sp>
         <p:nvSpPr>
-          <p:cNvPr id="7" name="Rectangle 6"/>
+          <p:cNvPr id="8" name="Rectangle 7"/>
           <p:cNvSpPr/>
           <p:nvPr/>
         </p:nvSpPr>
@@ -7393,7 +7535,7 @@
       </p:sp>
       <p:sp>
         <p:nvSpPr>
-          <p:cNvPr id="8" name="TextBox 7"/>
+          <p:cNvPr id="9" name="TextBox 8"/>
           <p:cNvSpPr txBox="1"/>
           <p:nvPr/>
         </p:nvSpPr>
@@ -7440,7 +7582,7 @@
       </p:sp>
       <p:sp>
         <p:nvSpPr>
-          <p:cNvPr id="9" name="Rounded Rectangle 8"/>
+          <p:cNvPr id="10" name="Rounded Rectangle 9"/>
           <p:cNvSpPr/>
           <p:nvPr/>
         </p:nvSpPr>
@@ -7494,7 +7636,7 @@
       </p:sp>
       <p:sp>
         <p:nvSpPr>
-          <p:cNvPr id="10" name="TextBox 9"/>
+          <p:cNvPr id="11" name="TextBox 10"/>
           <p:cNvSpPr txBox="1"/>
           <p:nvPr/>
         </p:nvSpPr>
@@ -7541,7 +7683,7 @@
       </p:sp>
       <p:sp>
         <p:nvSpPr>
-          <p:cNvPr id="11" name="Rectangle 10"/>
+          <p:cNvPr id="12" name="Rectangle 11"/>
           <p:cNvSpPr/>
           <p:nvPr/>
         </p:nvSpPr>
@@ -7585,7 +7727,7 @@
       </p:sp>
       <p:sp>
         <p:nvSpPr>
-          <p:cNvPr id="12" name="TextBox 11"/>
+          <p:cNvPr id="13" name="TextBox 12"/>
           <p:cNvSpPr txBox="1"/>
           <p:nvPr/>
         </p:nvSpPr>
@@ -7632,7 +7774,7 @@
       </p:sp>
       <p:sp>
         <p:nvSpPr>
-          <p:cNvPr id="13" name="TextBox 12"/>
+          <p:cNvPr id="14" name="TextBox 13"/>
           <p:cNvSpPr txBox="1"/>
           <p:nvPr/>
         </p:nvSpPr>
@@ -7679,7 +7821,7 @@
       </p:sp>
       <p:sp>
         <p:nvSpPr>
-          <p:cNvPr id="14" name="Rounded Rectangle 13"/>
+          <p:cNvPr id="15" name="Rounded Rectangle 14"/>
           <p:cNvSpPr/>
           <p:nvPr/>
         </p:nvSpPr>
@@ -7733,7 +7875,7 @@
       </p:sp>
       <p:sp>
         <p:nvSpPr>
-          <p:cNvPr id="15" name="TextBox 14"/>
+          <p:cNvPr id="16" name="TextBox 15"/>
           <p:cNvSpPr txBox="1"/>
           <p:nvPr/>
         </p:nvSpPr>
@@ -7780,7 +7922,7 @@
       </p:sp>
       <p:sp>
         <p:nvSpPr>
-          <p:cNvPr id="16" name="Rectangle 15"/>
+          <p:cNvPr id="17" name="Rectangle 16"/>
           <p:cNvSpPr/>
           <p:nvPr/>
         </p:nvSpPr>
@@ -7824,7 +7966,7 @@
       </p:sp>
       <p:sp>
         <p:nvSpPr>
-          <p:cNvPr id="17" name="TextBox 16"/>
+          <p:cNvPr id="18" name="TextBox 17"/>
           <p:cNvSpPr txBox="1"/>
           <p:nvPr/>
         </p:nvSpPr>
@@ -7871,7 +8013,7 @@
       </p:sp>
       <p:sp>
         <p:nvSpPr>
-          <p:cNvPr id="18" name="TextBox 17"/>
+          <p:cNvPr id="19" name="TextBox 18"/>
           <p:cNvSpPr txBox="1"/>
           <p:nvPr/>
         </p:nvSpPr>
@@ -7918,7 +8060,7 @@
       </p:sp>
       <p:sp>
         <p:nvSpPr>
-          <p:cNvPr id="19" name="Rounded Rectangle 18"/>
+          <p:cNvPr id="20" name="Rounded Rectangle 19"/>
           <p:cNvSpPr/>
           <p:nvPr/>
         </p:nvSpPr>
@@ -7972,7 +8114,7 @@
       </p:sp>
       <p:sp>
         <p:nvSpPr>
-          <p:cNvPr id="20" name="TextBox 19"/>
+          <p:cNvPr id="21" name="TextBox 20"/>
           <p:cNvSpPr txBox="1"/>
           <p:nvPr/>
         </p:nvSpPr>
@@ -8019,7 +8161,7 @@
       </p:sp>
       <p:sp>
         <p:nvSpPr>
-          <p:cNvPr id="21" name="Rectangle 20"/>
+          <p:cNvPr id="22" name="Rectangle 21"/>
           <p:cNvSpPr/>
           <p:nvPr/>
         </p:nvSpPr>
@@ -8063,7 +8205,7 @@
       </p:sp>
       <p:sp>
         <p:nvSpPr>
-          <p:cNvPr id="22" name="TextBox 21"/>
+          <p:cNvPr id="23" name="TextBox 22"/>
           <p:cNvSpPr txBox="1"/>
           <p:nvPr/>
         </p:nvSpPr>
@@ -8110,7 +8252,7 @@
       </p:sp>
       <p:sp>
         <p:nvSpPr>
-          <p:cNvPr id="23" name="TextBox 22"/>
+          <p:cNvPr id="24" name="TextBox 23"/>
           <p:cNvSpPr txBox="1"/>
           <p:nvPr/>
         </p:nvSpPr>
@@ -8157,7 +8299,7 @@
       </p:sp>
       <p:sp>
         <p:nvSpPr>
-          <p:cNvPr id="24" name="Rounded Rectangle 23"/>
+          <p:cNvPr id="25" name="Rounded Rectangle 24"/>
           <p:cNvSpPr/>
           <p:nvPr/>
         </p:nvSpPr>
@@ -8284,9 +8426,33 @@
           </a:p>
         </p:txBody>
       </p:sp>
-      <p:sp>
-        <p:nvSpPr>
-          <p:cNvPr id="3" name="TextBox 2"/>
+      <p:pic>
+        <p:nvPicPr>
+          <p:cNvPr id="3" name="college-logo" descr="logo-mark.png"/>
+          <p:cNvPicPr>
+            <a:picLocks noChangeAspect="1"/>
+          </p:cNvPicPr>
+          <p:nvPr/>
+        </p:nvPicPr>
+        <p:blipFill>
+          <a:blip r:embed="rId2"/>
+          <a:stretch>
+            <a:fillRect/>
+          </a:stretch>
+        </p:blipFill>
+        <p:spPr>
+          <a:xfrm>
+            <a:off x="11203333" y="6199632"/>
+            <a:ext cx="275129" cy="310896"/>
+          </a:xfrm>
+          <a:prstGeom prst="rect">
+            <a:avLst/>
+          </a:prstGeom>
+        </p:spPr>
+      </p:pic>
+      <p:sp>
+        <p:nvSpPr>
+          <p:cNvPr id="4" name="TextBox 3"/>
           <p:cNvSpPr txBox="1"/>
           <p:nvPr/>
         </p:nvSpPr>
@@ -8355,13 +8521,13 @@
       </p:sp>
       <p:sp>
         <p:nvSpPr>
-          <p:cNvPr id="4" name="TextBox 3"/>
+          <p:cNvPr id="5" name="TextBox 4"/>
           <p:cNvSpPr txBox="1"/>
           <p:nvPr/>
         </p:nvSpPr>
         <p:spPr>
           <a:xfrm>
-            <a:off x="8826703" y="6272784"/>
+            <a:off x="8240677" y="6272784"/>
             <a:ext cx="2651760" cy="219456"/>
           </a:xfrm>
           <a:prstGeom prst="rect">
@@ -8424,7 +8590,7 @@
       </p:sp>
       <p:sp>
         <p:nvSpPr>
-          <p:cNvPr id="5" name="TextBox 4"/>
+          <p:cNvPr id="6" name="TextBox 5"/>
           <p:cNvSpPr txBox="1"/>
           <p:nvPr/>
         </p:nvSpPr>
@@ -8471,7 +8637,7 @@
       </p:sp>
       <p:sp>
         <p:nvSpPr>
-          <p:cNvPr id="6" name="TextBox 5"/>
+          <p:cNvPr id="7" name="TextBox 6"/>
           <p:cNvSpPr txBox="1"/>
           <p:nvPr/>
         </p:nvSpPr>
@@ -8518,7 +8684,7 @@
       </p:sp>
       <p:sp>
         <p:nvSpPr>
-          <p:cNvPr id="7" name="Rectangle 6"/>
+          <p:cNvPr id="8" name="Rectangle 7"/>
           <p:cNvSpPr/>
           <p:nvPr/>
         </p:nvSpPr>
@@ -8562,7 +8728,7 @@
       </p:sp>
       <p:sp>
         <p:nvSpPr>
-          <p:cNvPr id="8" name="TextBox 7"/>
+          <p:cNvPr id="9" name="TextBox 8"/>
           <p:cNvSpPr txBox="1"/>
           <p:nvPr/>
         </p:nvSpPr>
@@ -8609,7 +8775,7 @@
       </p:sp>
       <p:sp>
         <p:nvSpPr>
-          <p:cNvPr id="9" name="Rounded Rectangle 8"/>
+          <p:cNvPr id="10" name="Rounded Rectangle 9"/>
           <p:cNvSpPr/>
           <p:nvPr/>
         </p:nvSpPr>
@@ -8663,7 +8829,7 @@
       </p:sp>
       <p:sp>
         <p:nvSpPr>
-          <p:cNvPr id="10" name="Rectangle 9"/>
+          <p:cNvPr id="11" name="Rectangle 10"/>
           <p:cNvSpPr/>
           <p:nvPr/>
         </p:nvSpPr>
@@ -8707,7 +8873,7 @@
       </p:sp>
       <p:sp>
         <p:nvSpPr>
-          <p:cNvPr id="11" name="TextBox 10"/>
+          <p:cNvPr id="12" name="TextBox 11"/>
           <p:cNvSpPr txBox="1"/>
           <p:nvPr/>
         </p:nvSpPr>
@@ -8754,7 +8920,7 @@
       </p:sp>
       <p:sp>
         <p:nvSpPr>
-          <p:cNvPr id="12" name="Rounded Rectangle 11"/>
+          <p:cNvPr id="13" name="Rounded Rectangle 12"/>
           <p:cNvSpPr/>
           <p:nvPr/>
         </p:nvSpPr>
@@ -8800,7 +8966,7 @@
       </p:sp>
       <p:sp>
         <p:nvSpPr>
-          <p:cNvPr id="13" name="TextBox 12"/>
+          <p:cNvPr id="14" name="TextBox 13"/>
           <p:cNvSpPr txBox="1"/>
           <p:nvPr/>
         </p:nvSpPr>
@@ -8847,7 +9013,7 @@
       </p:sp>
       <p:sp>
         <p:nvSpPr>
-          <p:cNvPr id="14" name="Rounded Rectangle 13"/>
+          <p:cNvPr id="15" name="Rounded Rectangle 14"/>
           <p:cNvSpPr/>
           <p:nvPr/>
         </p:nvSpPr>
@@ -8893,7 +9059,7 @@
       </p:sp>
       <p:sp>
         <p:nvSpPr>
-          <p:cNvPr id="15" name="TextBox 14"/>
+          <p:cNvPr id="16" name="TextBox 15"/>
           <p:cNvSpPr txBox="1"/>
           <p:nvPr/>
         </p:nvSpPr>
@@ -8940,7 +9106,7 @@
       </p:sp>
       <p:sp>
         <p:nvSpPr>
-          <p:cNvPr id="16" name="Rounded Rectangle 15"/>
+          <p:cNvPr id="17" name="Rounded Rectangle 16"/>
           <p:cNvSpPr/>
           <p:nvPr/>
         </p:nvSpPr>
@@ -8994,7 +9160,7 @@
       </p:sp>
       <p:sp>
         <p:nvSpPr>
-          <p:cNvPr id="17" name="Rectangle 16"/>
+          <p:cNvPr id="18" name="Rectangle 17"/>
           <p:cNvSpPr/>
           <p:nvPr/>
         </p:nvSpPr>
@@ -9038,7 +9204,7 @@
       </p:sp>
       <p:sp>
         <p:nvSpPr>
-          <p:cNvPr id="18" name="TextBox 17"/>
+          <p:cNvPr id="19" name="TextBox 18"/>
           <p:cNvSpPr txBox="1"/>
           <p:nvPr/>
         </p:nvSpPr>
@@ -9085,7 +9251,7 @@
       </p:sp>
       <p:sp>
         <p:nvSpPr>
-          <p:cNvPr id="19" name="Rounded Rectangle 18"/>
+          <p:cNvPr id="20" name="Rounded Rectangle 19"/>
           <p:cNvSpPr/>
           <p:nvPr/>
         </p:nvSpPr>
@@ -9131,7 +9297,7 @@
       </p:sp>
       <p:sp>
         <p:nvSpPr>
-          <p:cNvPr id="20" name="TextBox 19"/>
+          <p:cNvPr id="21" name="TextBox 20"/>
           <p:cNvSpPr txBox="1"/>
           <p:nvPr/>
         </p:nvSpPr>
@@ -9178,7 +9344,7 @@
       </p:sp>
       <p:sp>
         <p:nvSpPr>
-          <p:cNvPr id="21" name="Rounded Rectangle 20"/>
+          <p:cNvPr id="22" name="Rounded Rectangle 21"/>
           <p:cNvSpPr/>
           <p:nvPr/>
         </p:nvSpPr>
@@ -9224,7 +9390,7 @@
       </p:sp>
       <p:sp>
         <p:nvSpPr>
-          <p:cNvPr id="22" name="TextBox 21"/>
+          <p:cNvPr id="23" name="TextBox 22"/>
           <p:cNvSpPr txBox="1"/>
           <p:nvPr/>
         </p:nvSpPr>
@@ -9271,7 +9437,7 @@
       </p:sp>
       <p:sp>
         <p:nvSpPr>
-          <p:cNvPr id="23" name="Rounded Rectangle 22"/>
+          <p:cNvPr id="24" name="Rounded Rectangle 23"/>
           <p:cNvSpPr/>
           <p:nvPr/>
         </p:nvSpPr>
@@ -9325,7 +9491,7 @@
       </p:sp>
       <p:sp>
         <p:nvSpPr>
-          <p:cNvPr id="24" name="Rectangle 23"/>
+          <p:cNvPr id="25" name="Rectangle 24"/>
           <p:cNvSpPr/>
           <p:nvPr/>
         </p:nvSpPr>
@@ -9369,7 +9535,7 @@
       </p:sp>
       <p:sp>
         <p:nvSpPr>
-          <p:cNvPr id="25" name="TextBox 24"/>
+          <p:cNvPr id="26" name="TextBox 25"/>
           <p:cNvSpPr txBox="1"/>
           <p:nvPr/>
         </p:nvSpPr>
@@ -9416,7 +9582,7 @@
       </p:sp>
       <p:sp>
         <p:nvSpPr>
-          <p:cNvPr id="26" name="Rounded Rectangle 25"/>
+          <p:cNvPr id="27" name="Rounded Rectangle 26"/>
           <p:cNvSpPr/>
           <p:nvPr/>
         </p:nvSpPr>
@@ -9462,7 +9628,7 @@
       </p:sp>
       <p:sp>
         <p:nvSpPr>
-          <p:cNvPr id="27" name="TextBox 26"/>
+          <p:cNvPr id="28" name="TextBox 27"/>
           <p:cNvSpPr txBox="1"/>
           <p:nvPr/>
         </p:nvSpPr>
@@ -9509,7 +9675,7 @@
       </p:sp>
       <p:sp>
         <p:nvSpPr>
-          <p:cNvPr id="28" name="Rounded Rectangle 27"/>
+          <p:cNvPr id="29" name="Rounded Rectangle 28"/>
           <p:cNvSpPr/>
           <p:nvPr/>
         </p:nvSpPr>
@@ -9555,7 +9721,7 @@
       </p:sp>
       <p:sp>
         <p:nvSpPr>
-          <p:cNvPr id="29" name="TextBox 28"/>
+          <p:cNvPr id="30" name="TextBox 29"/>
           <p:cNvSpPr txBox="1"/>
           <p:nvPr/>
         </p:nvSpPr>
@@ -9602,7 +9768,7 @@
       </p:sp>
       <p:sp>
         <p:nvSpPr>
-          <p:cNvPr id="30" name="Rounded Rectangle 29"/>
+          <p:cNvPr id="31" name="Rounded Rectangle 30"/>
           <p:cNvSpPr/>
           <p:nvPr/>
         </p:nvSpPr>
@@ -9656,7 +9822,7 @@
       </p:sp>
       <p:sp>
         <p:nvSpPr>
-          <p:cNvPr id="31" name="Rectangle 30"/>
+          <p:cNvPr id="32" name="Rectangle 31"/>
           <p:cNvSpPr/>
           <p:nvPr/>
         </p:nvSpPr>
@@ -9700,7 +9866,7 @@
       </p:sp>
       <p:sp>
         <p:nvSpPr>
-          <p:cNvPr id="32" name="TextBox 31"/>
+          <p:cNvPr id="33" name="TextBox 32"/>
           <p:cNvSpPr txBox="1"/>
           <p:nvPr/>
         </p:nvSpPr>
@@ -9747,7 +9913,7 @@
       </p:sp>
       <p:sp>
         <p:nvSpPr>
-          <p:cNvPr id="33" name="Rounded Rectangle 32"/>
+          <p:cNvPr id="34" name="Rounded Rectangle 33"/>
           <p:cNvSpPr/>
           <p:nvPr/>
         </p:nvSpPr>
@@ -9793,7 +9959,7 @@
       </p:sp>
       <p:sp>
         <p:nvSpPr>
-          <p:cNvPr id="34" name="TextBox 33"/>
+          <p:cNvPr id="35" name="TextBox 34"/>
           <p:cNvSpPr txBox="1"/>
           <p:nvPr/>
         </p:nvSpPr>
@@ -9840,7 +10006,7 @@
       </p:sp>
       <p:sp>
         <p:nvSpPr>
-          <p:cNvPr id="35" name="Rounded Rectangle 34"/>
+          <p:cNvPr id="36" name="Rounded Rectangle 35"/>
           <p:cNvSpPr/>
           <p:nvPr/>
         </p:nvSpPr>
@@ -9886,7 +10052,7 @@
       </p:sp>
       <p:sp>
         <p:nvSpPr>
-          <p:cNvPr id="36" name="TextBox 35"/>
+          <p:cNvPr id="37" name="TextBox 36"/>
           <p:cNvSpPr txBox="1"/>
           <p:nvPr/>
         </p:nvSpPr>
@@ -10369,6 +10535,76 @@
           </a:p>
         </p:txBody>
       </p:sp>
+      <p:sp>
+        <p:nvSpPr>
+          <p:cNvPr id="11" name="logo-plate"/>
+          <p:cNvSpPr/>
+          <p:nvPr/>
+        </p:nvSpPr>
+        <p:spPr>
+          <a:xfrm>
+            <a:off x="9512190" y="539496"/>
+            <a:ext cx="1993704" cy="987552"/>
+          </a:xfrm>
+          <a:prstGeom prst="roundRect">
+            <a:avLst>
+              <a:gd name="adj" fmla="val 14000"/>
+            </a:avLst>
+          </a:prstGeom>
+          <a:solidFill>
+            <a:srgbClr val="FFFFFF"/>
+          </a:solidFill>
+          <a:ln>
+            <a:noFill/>
+          </a:ln>
+          <a:effectLst/>
+        </p:spPr>
+        <p:style>
+          <a:lnRef idx="1">
+            <a:schemeClr val="accent1"/>
+          </a:lnRef>
+          <a:fillRef idx="3">
+            <a:schemeClr val="accent1"/>
+          </a:fillRef>
+          <a:effectRef idx="2">
+            <a:schemeClr val="accent1"/>
+          </a:effectRef>
+          <a:fontRef idx="minor">
+            <a:schemeClr val="lt1"/>
+          </a:fontRef>
+        </p:style>
+        <p:txBody>
+          <a:bodyPr rtlCol="0" anchor="ctr" wrap="square"/>
+          <a:lstStyle/>
+          <a:p>
+            <a:pPr algn="ctr"/>
+          </a:p>
+        </p:txBody>
+      </p:sp>
+      <p:pic>
+        <p:nvPicPr>
+          <p:cNvPr id="12" name="college-logo" descr="logo-full.png"/>
+          <p:cNvPicPr>
+            <a:picLocks noChangeAspect="1"/>
+          </p:cNvPicPr>
+          <p:nvPr/>
+        </p:nvPicPr>
+        <p:blipFill>
+          <a:blip r:embed="rId2"/>
+          <a:stretch>
+            <a:fillRect/>
+          </a:stretch>
+        </p:blipFill>
+        <p:spPr>
+          <a:xfrm>
+            <a:off x="9631062" y="658368"/>
+            <a:ext cx="1755961" cy="749808"/>
+          </a:xfrm>
+          <a:prstGeom prst="rect">
+            <a:avLst/>
+          </a:prstGeom>
+        </p:spPr>
+      </p:pic>
     </p:spTree>
   </p:cSld>
   <p:clrMapOvr>
@@ -10431,9 +10667,33 @@
           </a:p>
         </p:txBody>
       </p:sp>
-      <p:sp>
-        <p:nvSpPr>
-          <p:cNvPr id="3" name="TextBox 2"/>
+      <p:pic>
+        <p:nvPicPr>
+          <p:cNvPr id="3" name="college-logo" descr="logo-mark.png"/>
+          <p:cNvPicPr>
+            <a:picLocks noChangeAspect="1"/>
+          </p:cNvPicPr>
+          <p:nvPr/>
+        </p:nvPicPr>
+        <p:blipFill>
+          <a:blip r:embed="rId2"/>
+          <a:stretch>
+            <a:fillRect/>
+          </a:stretch>
+        </p:blipFill>
+        <p:spPr>
+          <a:xfrm>
+            <a:off x="11203333" y="6199632"/>
+            <a:ext cx="275129" cy="310896"/>
+          </a:xfrm>
+          <a:prstGeom prst="rect">
+            <a:avLst/>
+          </a:prstGeom>
+        </p:spPr>
+      </p:pic>
+      <p:sp>
+        <p:nvSpPr>
+          <p:cNvPr id="4" name="TextBox 3"/>
           <p:cNvSpPr txBox="1"/>
           <p:nvPr/>
         </p:nvSpPr>
@@ -10502,13 +10762,13 @@
       </p:sp>
       <p:sp>
         <p:nvSpPr>
-          <p:cNvPr id="4" name="TextBox 3"/>
+          <p:cNvPr id="5" name="TextBox 4"/>
           <p:cNvSpPr txBox="1"/>
           <p:nvPr/>
         </p:nvSpPr>
         <p:spPr>
           <a:xfrm>
-            <a:off x="8826703" y="6272784"/>
+            <a:off x="8240677" y="6272784"/>
             <a:ext cx="2651760" cy="219456"/>
           </a:xfrm>
           <a:prstGeom prst="rect">
@@ -10571,7 +10831,7 @@
       </p:sp>
       <p:sp>
         <p:nvSpPr>
-          <p:cNvPr id="5" name="TextBox 4"/>
+          <p:cNvPr id="6" name="TextBox 5"/>
           <p:cNvSpPr txBox="1"/>
           <p:nvPr/>
         </p:nvSpPr>
@@ -10618,7 +10878,7 @@
       </p:sp>
       <p:sp>
         <p:nvSpPr>
-          <p:cNvPr id="6" name="TextBox 5"/>
+          <p:cNvPr id="7" name="TextBox 6"/>
           <p:cNvSpPr txBox="1"/>
           <p:nvPr/>
         </p:nvSpPr>
@@ -10665,7 +10925,7 @@
       </p:sp>
       <p:sp>
         <p:nvSpPr>
-          <p:cNvPr id="7" name="Rectangle 6"/>
+          <p:cNvPr id="8" name="Rectangle 7"/>
           <p:cNvSpPr/>
           <p:nvPr/>
         </p:nvSpPr>
@@ -10709,7 +10969,7 @@
       </p:sp>
       <p:sp>
         <p:nvSpPr>
-          <p:cNvPr id="8" name="TextBox 7"/>
+          <p:cNvPr id="9" name="TextBox 8"/>
           <p:cNvSpPr txBox="1"/>
           <p:nvPr/>
         </p:nvSpPr>
@@ -10756,7 +11016,7 @@
       </p:sp>
       <p:sp>
         <p:nvSpPr>
-          <p:cNvPr id="9" name="Rounded Rectangle 8"/>
+          <p:cNvPr id="10" name="Rounded Rectangle 9"/>
           <p:cNvSpPr/>
           <p:nvPr/>
         </p:nvSpPr>
@@ -10810,7 +11070,7 @@
       </p:sp>
       <p:sp>
         <p:nvSpPr>
-          <p:cNvPr id="10" name="Rectangle 9"/>
+          <p:cNvPr id="11" name="Rectangle 10"/>
           <p:cNvSpPr/>
           <p:nvPr/>
         </p:nvSpPr>
@@ -10854,7 +11114,7 @@
       </p:sp>
       <p:sp>
         <p:nvSpPr>
-          <p:cNvPr id="11" name="TextBox 10"/>
+          <p:cNvPr id="12" name="TextBox 11"/>
           <p:cNvSpPr txBox="1"/>
           <p:nvPr/>
         </p:nvSpPr>
@@ -10901,7 +11161,7 @@
       </p:sp>
       <p:sp>
         <p:nvSpPr>
-          <p:cNvPr id="12" name="TextBox 11"/>
+          <p:cNvPr id="13" name="TextBox 12"/>
           <p:cNvSpPr txBox="1"/>
           <p:nvPr/>
         </p:nvSpPr>
@@ -10948,7 +11208,7 @@
       </p:sp>
       <p:sp>
         <p:nvSpPr>
-          <p:cNvPr id="13" name="Rounded Rectangle 12"/>
+          <p:cNvPr id="14" name="Rounded Rectangle 13"/>
           <p:cNvSpPr/>
           <p:nvPr/>
         </p:nvSpPr>
@@ -11002,7 +11262,7 @@
       </p:sp>
       <p:sp>
         <p:nvSpPr>
-          <p:cNvPr id="14" name="Rectangle 13"/>
+          <p:cNvPr id="15" name="Rectangle 14"/>
           <p:cNvSpPr/>
           <p:nvPr/>
         </p:nvSpPr>
@@ -11046,7 +11306,7 @@
       </p:sp>
       <p:sp>
         <p:nvSpPr>
-          <p:cNvPr id="15" name="TextBox 14"/>
+          <p:cNvPr id="16" name="TextBox 15"/>
           <p:cNvSpPr txBox="1"/>
           <p:nvPr/>
         </p:nvSpPr>
@@ -11093,7 +11353,7 @@
       </p:sp>
       <p:sp>
         <p:nvSpPr>
-          <p:cNvPr id="16" name="TextBox 15"/>
+          <p:cNvPr id="17" name="TextBox 16"/>
           <p:cNvSpPr txBox="1"/>
           <p:nvPr/>
         </p:nvSpPr>
@@ -11140,7 +11400,7 @@
       </p:sp>
       <p:sp>
         <p:nvSpPr>
-          <p:cNvPr id="17" name="Rounded Rectangle 16"/>
+          <p:cNvPr id="18" name="Rounded Rectangle 17"/>
           <p:cNvSpPr/>
           <p:nvPr/>
         </p:nvSpPr>
@@ -11194,7 +11454,7 @@
       </p:sp>
       <p:sp>
         <p:nvSpPr>
-          <p:cNvPr id="18" name="Rectangle 17"/>
+          <p:cNvPr id="19" name="Rectangle 18"/>
           <p:cNvSpPr/>
           <p:nvPr/>
         </p:nvSpPr>
@@ -11238,7 +11498,7 @@
       </p:sp>
       <p:sp>
         <p:nvSpPr>
-          <p:cNvPr id="19" name="TextBox 18"/>
+          <p:cNvPr id="20" name="TextBox 19"/>
           <p:cNvSpPr txBox="1"/>
           <p:nvPr/>
         </p:nvSpPr>
@@ -11285,7 +11545,7 @@
       </p:sp>
       <p:sp>
         <p:nvSpPr>
-          <p:cNvPr id="20" name="TextBox 19"/>
+          <p:cNvPr id="21" name="TextBox 20"/>
           <p:cNvSpPr txBox="1"/>
           <p:nvPr/>
         </p:nvSpPr>
@@ -11332,7 +11592,7 @@
       </p:sp>
       <p:sp>
         <p:nvSpPr>
-          <p:cNvPr id="21" name="Rounded Rectangle 20"/>
+          <p:cNvPr id="22" name="Rounded Rectangle 21"/>
           <p:cNvSpPr/>
           <p:nvPr/>
         </p:nvSpPr>
@@ -11386,7 +11646,7 @@
       </p:sp>
       <p:sp>
         <p:nvSpPr>
-          <p:cNvPr id="22" name="Rectangle 21"/>
+          <p:cNvPr id="23" name="Rectangle 22"/>
           <p:cNvSpPr/>
           <p:nvPr/>
         </p:nvSpPr>
@@ -11430,7 +11690,7 @@
       </p:sp>
       <p:sp>
         <p:nvSpPr>
-          <p:cNvPr id="23" name="TextBox 22"/>
+          <p:cNvPr id="24" name="TextBox 23"/>
           <p:cNvSpPr txBox="1"/>
           <p:nvPr/>
         </p:nvSpPr>
@@ -11477,7 +11737,7 @@
       </p:sp>
       <p:sp>
         <p:nvSpPr>
-          <p:cNvPr id="24" name="TextBox 23"/>
+          <p:cNvPr id="25" name="TextBox 24"/>
           <p:cNvSpPr txBox="1"/>
           <p:nvPr/>
         </p:nvSpPr>
@@ -11524,7 +11784,7 @@
       </p:sp>
       <p:sp>
         <p:nvSpPr>
-          <p:cNvPr id="25" name="Rounded Rectangle 24"/>
+          <p:cNvPr id="26" name="Rounded Rectangle 25"/>
           <p:cNvSpPr/>
           <p:nvPr/>
         </p:nvSpPr>
@@ -11578,7 +11838,7 @@
       </p:sp>
       <p:sp>
         <p:nvSpPr>
-          <p:cNvPr id="26" name="Rectangle 25"/>
+          <p:cNvPr id="27" name="Rectangle 26"/>
           <p:cNvSpPr/>
           <p:nvPr/>
         </p:nvSpPr>
@@ -11622,7 +11882,7 @@
       </p:sp>
       <p:sp>
         <p:nvSpPr>
-          <p:cNvPr id="27" name="TextBox 26"/>
+          <p:cNvPr id="28" name="TextBox 27"/>
           <p:cNvSpPr txBox="1"/>
           <p:nvPr/>
         </p:nvSpPr>
@@ -11669,7 +11929,7 @@
       </p:sp>
       <p:sp>
         <p:nvSpPr>
-          <p:cNvPr id="28" name="TextBox 27"/>
+          <p:cNvPr id="29" name="TextBox 28"/>
           <p:cNvSpPr txBox="1"/>
           <p:nvPr/>
         </p:nvSpPr>
@@ -11716,7 +11976,7 @@
       </p:sp>
       <p:sp>
         <p:nvSpPr>
-          <p:cNvPr id="29" name="Rounded Rectangle 28"/>
+          <p:cNvPr id="30" name="Rounded Rectangle 29"/>
           <p:cNvSpPr/>
           <p:nvPr/>
         </p:nvSpPr>
@@ -11770,7 +12030,7 @@
       </p:sp>
       <p:sp>
         <p:nvSpPr>
-          <p:cNvPr id="30" name="Rectangle 29"/>
+          <p:cNvPr id="31" name="Rectangle 30"/>
           <p:cNvSpPr/>
           <p:nvPr/>
         </p:nvSpPr>
@@ -11814,7 +12074,7 @@
       </p:sp>
       <p:sp>
         <p:nvSpPr>
-          <p:cNvPr id="31" name="TextBox 30"/>
+          <p:cNvPr id="32" name="TextBox 31"/>
           <p:cNvSpPr txBox="1"/>
           <p:nvPr/>
         </p:nvSpPr>
@@ -11861,7 +12121,7 @@
       </p:sp>
       <p:sp>
         <p:nvSpPr>
-          <p:cNvPr id="32" name="TextBox 31"/>
+          <p:cNvPr id="33" name="TextBox 32"/>
           <p:cNvSpPr txBox="1"/>
           <p:nvPr/>
         </p:nvSpPr>
@@ -12344,6 +12604,76 @@
           </a:p>
         </p:txBody>
       </p:sp>
+      <p:sp>
+        <p:nvSpPr>
+          <p:cNvPr id="11" name="logo-plate"/>
+          <p:cNvSpPr/>
+          <p:nvPr/>
+        </p:nvSpPr>
+        <p:spPr>
+          <a:xfrm>
+            <a:off x="9512190" y="539496"/>
+            <a:ext cx="1993704" cy="987552"/>
+          </a:xfrm>
+          <a:prstGeom prst="roundRect">
+            <a:avLst>
+              <a:gd name="adj" fmla="val 14000"/>
+            </a:avLst>
+          </a:prstGeom>
+          <a:solidFill>
+            <a:srgbClr val="FFFFFF"/>
+          </a:solidFill>
+          <a:ln>
+            <a:noFill/>
+          </a:ln>
+          <a:effectLst/>
+        </p:spPr>
+        <p:style>
+          <a:lnRef idx="1">
+            <a:schemeClr val="accent1"/>
+          </a:lnRef>
+          <a:fillRef idx="3">
+            <a:schemeClr val="accent1"/>
+          </a:fillRef>
+          <a:effectRef idx="2">
+            <a:schemeClr val="accent1"/>
+          </a:effectRef>
+          <a:fontRef idx="minor">
+            <a:schemeClr val="lt1"/>
+          </a:fontRef>
+        </p:style>
+        <p:txBody>
+          <a:bodyPr rtlCol="0" anchor="ctr" wrap="square"/>
+          <a:lstStyle/>
+          <a:p>
+            <a:pPr algn="ctr"/>
+          </a:p>
+        </p:txBody>
+      </p:sp>
+      <p:pic>
+        <p:nvPicPr>
+          <p:cNvPr id="12" name="college-logo" descr="logo-full.png"/>
+          <p:cNvPicPr>
+            <a:picLocks noChangeAspect="1"/>
+          </p:cNvPicPr>
+          <p:nvPr/>
+        </p:nvPicPr>
+        <p:blipFill>
+          <a:blip r:embed="rId2"/>
+          <a:stretch>
+            <a:fillRect/>
+          </a:stretch>
+        </p:blipFill>
+        <p:spPr>
+          <a:xfrm>
+            <a:off x="9631062" y="658368"/>
+            <a:ext cx="1755961" cy="749808"/>
+          </a:xfrm>
+          <a:prstGeom prst="rect">
+            <a:avLst/>
+          </a:prstGeom>
+        </p:spPr>
+      </p:pic>
     </p:spTree>
   </p:cSld>
   <p:clrMapOvr>
@@ -12406,9 +12736,33 @@
           </a:p>
         </p:txBody>
       </p:sp>
-      <p:sp>
-        <p:nvSpPr>
-          <p:cNvPr id="3" name="TextBox 2"/>
+      <p:pic>
+        <p:nvPicPr>
+          <p:cNvPr id="3" name="college-logo" descr="logo-mark.png"/>
+          <p:cNvPicPr>
+            <a:picLocks noChangeAspect="1"/>
+          </p:cNvPicPr>
+          <p:nvPr/>
+        </p:nvPicPr>
+        <p:blipFill>
+          <a:blip r:embed="rId2"/>
+          <a:stretch>
+            <a:fillRect/>
+          </a:stretch>
+        </p:blipFill>
+        <p:spPr>
+          <a:xfrm>
+            <a:off x="11203333" y="6199632"/>
+            <a:ext cx="275129" cy="310896"/>
+          </a:xfrm>
+          <a:prstGeom prst="rect">
+            <a:avLst/>
+          </a:prstGeom>
+        </p:spPr>
+      </p:pic>
+      <p:sp>
+        <p:nvSpPr>
+          <p:cNvPr id="4" name="TextBox 3"/>
           <p:cNvSpPr txBox="1"/>
           <p:nvPr/>
         </p:nvSpPr>
@@ -12477,13 +12831,13 @@
       </p:sp>
       <p:sp>
         <p:nvSpPr>
-          <p:cNvPr id="4" name="TextBox 3"/>
+          <p:cNvPr id="5" name="TextBox 4"/>
           <p:cNvSpPr txBox="1"/>
           <p:nvPr/>
         </p:nvSpPr>
         <p:spPr>
           <a:xfrm>
-            <a:off x="8826703" y="6272784"/>
+            <a:off x="8240677" y="6272784"/>
             <a:ext cx="2651760" cy="219456"/>
           </a:xfrm>
           <a:prstGeom prst="rect">
@@ -12546,7 +12900,7 @@
       </p:sp>
       <p:sp>
         <p:nvSpPr>
-          <p:cNvPr id="5" name="TextBox 4"/>
+          <p:cNvPr id="6" name="TextBox 5"/>
           <p:cNvSpPr txBox="1"/>
           <p:nvPr/>
         </p:nvSpPr>
@@ -12593,7 +12947,7 @@
       </p:sp>
       <p:sp>
         <p:nvSpPr>
-          <p:cNvPr id="6" name="TextBox 5"/>
+          <p:cNvPr id="7" name="TextBox 6"/>
           <p:cNvSpPr txBox="1"/>
           <p:nvPr/>
         </p:nvSpPr>
@@ -12640,7 +12994,7 @@
       </p:sp>
       <p:sp>
         <p:nvSpPr>
-          <p:cNvPr id="7" name="Rectangle 6"/>
+          <p:cNvPr id="8" name="Rectangle 7"/>
           <p:cNvSpPr/>
           <p:nvPr/>
         </p:nvSpPr>
@@ -12684,7 +13038,7 @@
       </p:sp>
       <p:sp>
         <p:nvSpPr>
-          <p:cNvPr id="8" name="TextBox 7"/>
+          <p:cNvPr id="9" name="TextBox 8"/>
           <p:cNvSpPr txBox="1"/>
           <p:nvPr/>
         </p:nvSpPr>
@@ -12731,7 +13085,7 @@
       </p:sp>
       <p:sp>
         <p:nvSpPr>
-          <p:cNvPr id="9" name="Rounded Rectangle 8"/>
+          <p:cNvPr id="10" name="Rounded Rectangle 9"/>
           <p:cNvSpPr/>
           <p:nvPr/>
         </p:nvSpPr>
@@ -12785,7 +13139,7 @@
       </p:sp>
       <p:sp>
         <p:nvSpPr>
-          <p:cNvPr id="10" name="Rectangle 9"/>
+          <p:cNvPr id="11" name="Rectangle 10"/>
           <p:cNvSpPr/>
           <p:nvPr/>
         </p:nvSpPr>
@@ -12829,7 +13183,7 @@
       </p:sp>
       <p:sp>
         <p:nvSpPr>
-          <p:cNvPr id="11" name="Oval 10"/>
+          <p:cNvPr id="12" name="Oval 11"/>
           <p:cNvSpPr/>
           <p:nvPr/>
         </p:nvSpPr>
@@ -12873,7 +13227,7 @@
       </p:sp>
       <p:sp>
         <p:nvSpPr>
-          <p:cNvPr id="12" name="TextBox 11"/>
+          <p:cNvPr id="13" name="TextBox 12"/>
           <p:cNvSpPr txBox="1"/>
           <p:nvPr/>
         </p:nvSpPr>
@@ -12920,7 +13274,7 @@
       </p:sp>
       <p:sp>
         <p:nvSpPr>
-          <p:cNvPr id="13" name="TextBox 12"/>
+          <p:cNvPr id="14" name="TextBox 13"/>
           <p:cNvSpPr txBox="1"/>
           <p:nvPr/>
         </p:nvSpPr>
@@ -12967,7 +13321,7 @@
       </p:sp>
       <p:sp>
         <p:nvSpPr>
-          <p:cNvPr id="14" name="TextBox 13"/>
+          <p:cNvPr id="15" name="TextBox 14"/>
           <p:cNvSpPr txBox="1"/>
           <p:nvPr/>
         </p:nvSpPr>
@@ -13014,7 +13368,7 @@
       </p:sp>
       <p:sp>
         <p:nvSpPr>
-          <p:cNvPr id="15" name="Rounded Rectangle 14"/>
+          <p:cNvPr id="16" name="Rounded Rectangle 15"/>
           <p:cNvSpPr/>
           <p:nvPr/>
         </p:nvSpPr>
@@ -13068,7 +13422,7 @@
       </p:sp>
       <p:sp>
         <p:nvSpPr>
-          <p:cNvPr id="16" name="Rectangle 15"/>
+          <p:cNvPr id="17" name="Rectangle 16"/>
           <p:cNvSpPr/>
           <p:nvPr/>
         </p:nvSpPr>
@@ -13112,7 +13466,7 @@
       </p:sp>
       <p:sp>
         <p:nvSpPr>
-          <p:cNvPr id="17" name="Oval 16"/>
+          <p:cNvPr id="18" name="Oval 17"/>
           <p:cNvSpPr/>
           <p:nvPr/>
         </p:nvSpPr>
@@ -13156,7 +13510,7 @@
       </p:sp>
       <p:sp>
         <p:nvSpPr>
-          <p:cNvPr id="18" name="TextBox 17"/>
+          <p:cNvPr id="19" name="TextBox 18"/>
           <p:cNvSpPr txBox="1"/>
           <p:nvPr/>
         </p:nvSpPr>
@@ -13203,7 +13557,7 @@
       </p:sp>
       <p:sp>
         <p:nvSpPr>
-          <p:cNvPr id="19" name="TextBox 18"/>
+          <p:cNvPr id="20" name="TextBox 19"/>
           <p:cNvSpPr txBox="1"/>
           <p:nvPr/>
         </p:nvSpPr>
@@ -13250,7 +13604,7 @@
       </p:sp>
       <p:sp>
         <p:nvSpPr>
-          <p:cNvPr id="20" name="TextBox 19"/>
+          <p:cNvPr id="21" name="TextBox 20"/>
           <p:cNvSpPr txBox="1"/>
           <p:nvPr/>
         </p:nvSpPr>
@@ -13297,7 +13651,7 @@
       </p:sp>
       <p:sp>
         <p:nvSpPr>
-          <p:cNvPr id="21" name="Rounded Rectangle 20"/>
+          <p:cNvPr id="22" name="Rounded Rectangle 21"/>
           <p:cNvSpPr/>
           <p:nvPr/>
         </p:nvSpPr>
@@ -13351,7 +13705,7 @@
       </p:sp>
       <p:sp>
         <p:nvSpPr>
-          <p:cNvPr id="22" name="Rectangle 21"/>
+          <p:cNvPr id="23" name="Rectangle 22"/>
           <p:cNvSpPr/>
           <p:nvPr/>
         </p:nvSpPr>
@@ -13395,7 +13749,7 @@
       </p:sp>
       <p:sp>
         <p:nvSpPr>
-          <p:cNvPr id="23" name="Oval 22"/>
+          <p:cNvPr id="24" name="Oval 23"/>
           <p:cNvSpPr/>
           <p:nvPr/>
         </p:nvSpPr>
@@ -13439,7 +13793,7 @@
       </p:sp>
       <p:sp>
         <p:nvSpPr>
-          <p:cNvPr id="24" name="TextBox 23"/>
+          <p:cNvPr id="25" name="TextBox 24"/>
           <p:cNvSpPr txBox="1"/>
           <p:nvPr/>
         </p:nvSpPr>
@@ -13486,7 +13840,7 @@
       </p:sp>
       <p:sp>
         <p:nvSpPr>
-          <p:cNvPr id="25" name="TextBox 24"/>
+          <p:cNvPr id="26" name="TextBox 25"/>
           <p:cNvSpPr txBox="1"/>
           <p:nvPr/>
         </p:nvSpPr>
@@ -13533,7 +13887,7 @@
       </p:sp>
       <p:sp>
         <p:nvSpPr>
-          <p:cNvPr id="26" name="TextBox 25"/>
+          <p:cNvPr id="27" name="TextBox 26"/>
           <p:cNvSpPr txBox="1"/>
           <p:nvPr/>
         </p:nvSpPr>
@@ -13580,7 +13934,7 @@
       </p:sp>
       <p:sp>
         <p:nvSpPr>
-          <p:cNvPr id="27" name="Rounded Rectangle 26"/>
+          <p:cNvPr id="28" name="Rounded Rectangle 27"/>
           <p:cNvSpPr/>
           <p:nvPr/>
         </p:nvSpPr>
@@ -13634,7 +13988,7 @@
       </p:sp>
       <p:sp>
         <p:nvSpPr>
-          <p:cNvPr id="28" name="Rectangle 27"/>
+          <p:cNvPr id="29" name="Rectangle 28"/>
           <p:cNvSpPr/>
           <p:nvPr/>
         </p:nvSpPr>
@@ -13678,7 +14032,7 @@
       </p:sp>
       <p:sp>
         <p:nvSpPr>
-          <p:cNvPr id="29" name="Oval 28"/>
+          <p:cNvPr id="30" name="Oval 29"/>
           <p:cNvSpPr/>
           <p:nvPr/>
         </p:nvSpPr>
@@ -13722,7 +14076,7 @@
       </p:sp>
       <p:sp>
         <p:nvSpPr>
-          <p:cNvPr id="30" name="TextBox 29"/>
+          <p:cNvPr id="31" name="TextBox 30"/>
           <p:cNvSpPr txBox="1"/>
           <p:nvPr/>
         </p:nvSpPr>
@@ -13769,7 +14123,7 @@
       </p:sp>
       <p:sp>
         <p:nvSpPr>
-          <p:cNvPr id="31" name="TextBox 30"/>
+          <p:cNvPr id="32" name="TextBox 31"/>
           <p:cNvSpPr txBox="1"/>
           <p:nvPr/>
         </p:nvSpPr>
@@ -13816,7 +14170,7 @@
       </p:sp>
       <p:sp>
         <p:nvSpPr>
-          <p:cNvPr id="32" name="TextBox 31"/>
+          <p:cNvPr id="33" name="TextBox 32"/>
           <p:cNvSpPr txBox="1"/>
           <p:nvPr/>
         </p:nvSpPr>
@@ -13863,7 +14217,7 @@
       </p:sp>
       <p:sp>
         <p:nvSpPr>
-          <p:cNvPr id="33" name="Rounded Rectangle 32"/>
+          <p:cNvPr id="34" name="Rounded Rectangle 33"/>
           <p:cNvSpPr/>
           <p:nvPr/>
         </p:nvSpPr>
@@ -13917,7 +14271,7 @@
       </p:sp>
       <p:sp>
         <p:nvSpPr>
-          <p:cNvPr id="34" name="Rectangle 33"/>
+          <p:cNvPr id="35" name="Rectangle 34"/>
           <p:cNvSpPr/>
           <p:nvPr/>
         </p:nvSpPr>
@@ -13961,7 +14315,7 @@
       </p:sp>
       <p:sp>
         <p:nvSpPr>
-          <p:cNvPr id="35" name="Oval 34"/>
+          <p:cNvPr id="36" name="Oval 35"/>
           <p:cNvSpPr/>
           <p:nvPr/>
         </p:nvSpPr>
@@ -14005,7 +14359,7 @@
       </p:sp>
       <p:sp>
         <p:nvSpPr>
-          <p:cNvPr id="36" name="TextBox 35"/>
+          <p:cNvPr id="37" name="TextBox 36"/>
           <p:cNvSpPr txBox="1"/>
           <p:nvPr/>
         </p:nvSpPr>
@@ -14052,7 +14406,7 @@
       </p:sp>
       <p:sp>
         <p:nvSpPr>
-          <p:cNvPr id="37" name="TextBox 36"/>
+          <p:cNvPr id="38" name="TextBox 37"/>
           <p:cNvSpPr txBox="1"/>
           <p:nvPr/>
         </p:nvSpPr>
@@ -14099,7 +14453,7 @@
       </p:sp>
       <p:sp>
         <p:nvSpPr>
-          <p:cNvPr id="38" name="TextBox 37"/>
+          <p:cNvPr id="39" name="TextBox 38"/>
           <p:cNvSpPr txBox="1"/>
           <p:nvPr/>
         </p:nvSpPr>
@@ -14206,9 +14560,33 @@
           </a:p>
         </p:txBody>
       </p:sp>
-      <p:sp>
-        <p:nvSpPr>
-          <p:cNvPr id="3" name="TextBox 2"/>
+      <p:pic>
+        <p:nvPicPr>
+          <p:cNvPr id="3" name="college-logo" descr="logo-mark.png"/>
+          <p:cNvPicPr>
+            <a:picLocks noChangeAspect="1"/>
+          </p:cNvPicPr>
+          <p:nvPr/>
+        </p:nvPicPr>
+        <p:blipFill>
+          <a:blip r:embed="rId2"/>
+          <a:stretch>
+            <a:fillRect/>
+          </a:stretch>
+        </p:blipFill>
+        <p:spPr>
+          <a:xfrm>
+            <a:off x="11203333" y="6199632"/>
+            <a:ext cx="275129" cy="310896"/>
+          </a:xfrm>
+          <a:prstGeom prst="rect">
+            <a:avLst/>
+          </a:prstGeom>
+        </p:spPr>
+      </p:pic>
+      <p:sp>
+        <p:nvSpPr>
+          <p:cNvPr id="4" name="TextBox 3"/>
           <p:cNvSpPr txBox="1"/>
           <p:nvPr/>
         </p:nvSpPr>
@@ -14277,13 +14655,13 @@
       </p:sp>
       <p:sp>
         <p:nvSpPr>
-          <p:cNvPr id="4" name="TextBox 3"/>
+          <p:cNvPr id="5" name="TextBox 4"/>
           <p:cNvSpPr txBox="1"/>
           <p:nvPr/>
         </p:nvSpPr>
         <p:spPr>
           <a:xfrm>
-            <a:off x="8826703" y="6272784"/>
+            <a:off x="8240677" y="6272784"/>
             <a:ext cx="2651760" cy="219456"/>
           </a:xfrm>
           <a:prstGeom prst="rect">
@@ -14346,7 +14724,7 @@
       </p:sp>
       <p:sp>
         <p:nvSpPr>
-          <p:cNvPr id="5" name="TextBox 4"/>
+          <p:cNvPr id="6" name="TextBox 5"/>
           <p:cNvSpPr txBox="1"/>
           <p:nvPr/>
         </p:nvSpPr>
@@ -14393,7 +14771,7 @@
       </p:sp>
       <p:sp>
         <p:nvSpPr>
-          <p:cNvPr id="6" name="TextBox 5"/>
+          <p:cNvPr id="7" name="TextBox 6"/>
           <p:cNvSpPr txBox="1"/>
           <p:nvPr/>
         </p:nvSpPr>
@@ -14440,7 +14818,7 @@
       </p:sp>
       <p:sp>
         <p:nvSpPr>
-          <p:cNvPr id="7" name="Rectangle 6"/>
+          <p:cNvPr id="8" name="Rectangle 7"/>
           <p:cNvSpPr/>
           <p:nvPr/>
         </p:nvSpPr>
@@ -14484,7 +14862,7 @@
       </p:sp>
       <p:graphicFrame>
         <p:nvGraphicFramePr>
-          <p:cNvPr id="8" name="Table 7"/>
+          <p:cNvPr id="9" name="Table 8"/>
           <p:cNvGraphicFramePr>
             <a:graphicFrameLocks noGrp="1"/>
           </p:cNvGraphicFramePr>
@@ -15364,7 +15742,7 @@
       </p:graphicFrame>
       <p:sp>
         <p:nvSpPr>
-          <p:cNvPr id="9" name="Rounded Rectangle 8"/>
+          <p:cNvPr id="10" name="Rounded Rectangle 9"/>
           <p:cNvSpPr/>
           <p:nvPr/>
         </p:nvSpPr>
@@ -15431,7 +15809,7 @@
       </p:sp>
       <p:sp>
         <p:nvSpPr>
-          <p:cNvPr id="10" name="Rectangle 9"/>
+          <p:cNvPr id="11" name="Rectangle 10"/>
           <p:cNvSpPr/>
           <p:nvPr/>
         </p:nvSpPr>
@@ -15535,9 +15913,33 @@
           </a:p>
         </p:txBody>
       </p:sp>
-      <p:sp>
-        <p:nvSpPr>
-          <p:cNvPr id="3" name="TextBox 2"/>
+      <p:pic>
+        <p:nvPicPr>
+          <p:cNvPr id="3" name="college-logo" descr="logo-mark.png"/>
+          <p:cNvPicPr>
+            <a:picLocks noChangeAspect="1"/>
+          </p:cNvPicPr>
+          <p:nvPr/>
+        </p:nvPicPr>
+        <p:blipFill>
+          <a:blip r:embed="rId2"/>
+          <a:stretch>
+            <a:fillRect/>
+          </a:stretch>
+        </p:blipFill>
+        <p:spPr>
+          <a:xfrm>
+            <a:off x="11203333" y="6199632"/>
+            <a:ext cx="275129" cy="310896"/>
+          </a:xfrm>
+          <a:prstGeom prst="rect">
+            <a:avLst/>
+          </a:prstGeom>
+        </p:spPr>
+      </p:pic>
+      <p:sp>
+        <p:nvSpPr>
+          <p:cNvPr id="4" name="TextBox 3"/>
           <p:cNvSpPr txBox="1"/>
           <p:nvPr/>
         </p:nvSpPr>
@@ -15606,13 +16008,13 @@
       </p:sp>
       <p:sp>
         <p:nvSpPr>
-          <p:cNvPr id="4" name="TextBox 3"/>
+          <p:cNvPr id="5" name="TextBox 4"/>
           <p:cNvSpPr txBox="1"/>
           <p:nvPr/>
         </p:nvSpPr>
         <p:spPr>
           <a:xfrm>
-            <a:off x="8826703" y="6272784"/>
+            <a:off x="8240677" y="6272784"/>
             <a:ext cx="2651760" cy="219456"/>
           </a:xfrm>
           <a:prstGeom prst="rect">
@@ -15675,7 +16077,7 @@
       </p:sp>
       <p:sp>
         <p:nvSpPr>
-          <p:cNvPr id="5" name="TextBox 4"/>
+          <p:cNvPr id="6" name="TextBox 5"/>
           <p:cNvSpPr txBox="1"/>
           <p:nvPr/>
         </p:nvSpPr>
@@ -15722,7 +16124,7 @@
       </p:sp>
       <p:sp>
         <p:nvSpPr>
-          <p:cNvPr id="6" name="TextBox 5"/>
+          <p:cNvPr id="7" name="TextBox 6"/>
           <p:cNvSpPr txBox="1"/>
           <p:nvPr/>
         </p:nvSpPr>
@@ -15769,7 +16171,7 @@
       </p:sp>
       <p:sp>
         <p:nvSpPr>
-          <p:cNvPr id="7" name="Rectangle 6"/>
+          <p:cNvPr id="8" name="Rectangle 7"/>
           <p:cNvSpPr/>
           <p:nvPr/>
         </p:nvSpPr>
@@ -15813,7 +16215,7 @@
       </p:sp>
       <p:sp>
         <p:nvSpPr>
-          <p:cNvPr id="8" name="TextBox 7"/>
+          <p:cNvPr id="9" name="TextBox 8"/>
           <p:cNvSpPr txBox="1"/>
           <p:nvPr/>
         </p:nvSpPr>
@@ -15860,7 +16262,7 @@
       </p:sp>
       <p:sp>
         <p:nvSpPr>
-          <p:cNvPr id="9" name="Rounded Rectangle 8"/>
+          <p:cNvPr id="10" name="Rounded Rectangle 9"/>
           <p:cNvSpPr/>
           <p:nvPr/>
         </p:nvSpPr>
@@ -15906,7 +16308,7 @@
       </p:sp>
       <p:sp>
         <p:nvSpPr>
-          <p:cNvPr id="10" name="TextBox 9"/>
+          <p:cNvPr id="11" name="TextBox 10"/>
           <p:cNvSpPr txBox="1"/>
           <p:nvPr/>
         </p:nvSpPr>
@@ -15977,7 +16379,7 @@
       </p:sp>
       <p:sp>
         <p:nvSpPr>
-          <p:cNvPr id="11" name="Rounded Rectangle 10"/>
+          <p:cNvPr id="12" name="Rounded Rectangle 11"/>
           <p:cNvSpPr/>
           <p:nvPr/>
         </p:nvSpPr>
@@ -16023,7 +16425,7 @@
       </p:sp>
       <p:sp>
         <p:nvSpPr>
-          <p:cNvPr id="12" name="TextBox 11"/>
+          <p:cNvPr id="13" name="TextBox 12"/>
           <p:cNvSpPr txBox="1"/>
           <p:nvPr/>
         </p:nvSpPr>
@@ -16094,7 +16496,7 @@
       </p:sp>
       <p:sp>
         <p:nvSpPr>
-          <p:cNvPr id="13" name="Rounded Rectangle 12"/>
+          <p:cNvPr id="14" name="Rounded Rectangle 13"/>
           <p:cNvSpPr/>
           <p:nvPr/>
         </p:nvSpPr>
@@ -16140,7 +16542,7 @@
       </p:sp>
       <p:sp>
         <p:nvSpPr>
-          <p:cNvPr id="14" name="TextBox 13"/>
+          <p:cNvPr id="15" name="TextBox 14"/>
           <p:cNvSpPr txBox="1"/>
           <p:nvPr/>
         </p:nvSpPr>
@@ -16211,7 +16613,7 @@
       </p:sp>
       <p:sp>
         <p:nvSpPr>
-          <p:cNvPr id="15" name="Rounded Rectangle 14"/>
+          <p:cNvPr id="16" name="Rounded Rectangle 15"/>
           <p:cNvSpPr/>
           <p:nvPr/>
         </p:nvSpPr>
@@ -16257,7 +16659,7 @@
       </p:sp>
       <p:sp>
         <p:nvSpPr>
-          <p:cNvPr id="16" name="TextBox 15"/>
+          <p:cNvPr id="17" name="TextBox 16"/>
           <p:cNvSpPr txBox="1"/>
           <p:nvPr/>
         </p:nvSpPr>
@@ -16328,7 +16730,7 @@
       </p:sp>
       <p:sp>
         <p:nvSpPr>
-          <p:cNvPr id="17" name="Rounded Rectangle 16"/>
+          <p:cNvPr id="18" name="Rounded Rectangle 17"/>
           <p:cNvSpPr/>
           <p:nvPr/>
         </p:nvSpPr>
@@ -16374,7 +16776,7 @@
       </p:sp>
       <p:sp>
         <p:nvSpPr>
-          <p:cNvPr id="18" name="TextBox 17"/>
+          <p:cNvPr id="19" name="TextBox 18"/>
           <p:cNvSpPr txBox="1"/>
           <p:nvPr/>
         </p:nvSpPr>
@@ -16445,7 +16847,7 @@
       </p:sp>
       <p:sp>
         <p:nvSpPr>
-          <p:cNvPr id="19" name="Rounded Rectangle 18"/>
+          <p:cNvPr id="20" name="Rounded Rectangle 19"/>
           <p:cNvSpPr/>
           <p:nvPr/>
         </p:nvSpPr>
@@ -16491,7 +16893,7 @@
       </p:sp>
       <p:sp>
         <p:nvSpPr>
-          <p:cNvPr id="20" name="TextBox 19"/>
+          <p:cNvPr id="21" name="TextBox 20"/>
           <p:cNvSpPr txBox="1"/>
           <p:nvPr/>
         </p:nvSpPr>
@@ -16622,9 +17024,33 @@
           </a:p>
         </p:txBody>
       </p:sp>
-      <p:sp>
-        <p:nvSpPr>
-          <p:cNvPr id="3" name="TextBox 2"/>
+      <p:pic>
+        <p:nvPicPr>
+          <p:cNvPr id="3" name="college-logo" descr="logo-mark.png"/>
+          <p:cNvPicPr>
+            <a:picLocks noChangeAspect="1"/>
+          </p:cNvPicPr>
+          <p:nvPr/>
+        </p:nvPicPr>
+        <p:blipFill>
+          <a:blip r:embed="rId2"/>
+          <a:stretch>
+            <a:fillRect/>
+          </a:stretch>
+        </p:blipFill>
+        <p:spPr>
+          <a:xfrm>
+            <a:off x="11203333" y="6199632"/>
+            <a:ext cx="275129" cy="310896"/>
+          </a:xfrm>
+          <a:prstGeom prst="rect">
+            <a:avLst/>
+          </a:prstGeom>
+        </p:spPr>
+      </p:pic>
+      <p:sp>
+        <p:nvSpPr>
+          <p:cNvPr id="4" name="TextBox 3"/>
           <p:cNvSpPr txBox="1"/>
           <p:nvPr/>
         </p:nvSpPr>
@@ -16693,13 +17119,13 @@
       </p:sp>
       <p:sp>
         <p:nvSpPr>
-          <p:cNvPr id="4" name="TextBox 3"/>
+          <p:cNvPr id="5" name="TextBox 4"/>
           <p:cNvSpPr txBox="1"/>
           <p:nvPr/>
         </p:nvSpPr>
         <p:spPr>
           <a:xfrm>
-            <a:off x="8826703" y="6272784"/>
+            <a:off x="8240677" y="6272784"/>
             <a:ext cx="2651760" cy="219456"/>
           </a:xfrm>
           <a:prstGeom prst="rect">
@@ -16762,7 +17188,7 @@
       </p:sp>
       <p:sp>
         <p:nvSpPr>
-          <p:cNvPr id="5" name="TextBox 4"/>
+          <p:cNvPr id="6" name="TextBox 5"/>
           <p:cNvSpPr txBox="1"/>
           <p:nvPr/>
         </p:nvSpPr>
@@ -16809,7 +17235,7 @@
       </p:sp>
       <p:sp>
         <p:nvSpPr>
-          <p:cNvPr id="6" name="TextBox 5"/>
+          <p:cNvPr id="7" name="TextBox 6"/>
           <p:cNvSpPr txBox="1"/>
           <p:nvPr/>
         </p:nvSpPr>
@@ -16856,7 +17282,7 @@
       </p:sp>
       <p:sp>
         <p:nvSpPr>
-          <p:cNvPr id="7" name="Rectangle 6"/>
+          <p:cNvPr id="8" name="Rectangle 7"/>
           <p:cNvSpPr/>
           <p:nvPr/>
         </p:nvSpPr>
@@ -16900,7 +17326,7 @@
       </p:sp>
       <p:sp>
         <p:nvSpPr>
-          <p:cNvPr id="8" name="TextBox 7"/>
+          <p:cNvPr id="9" name="TextBox 8"/>
           <p:cNvSpPr txBox="1"/>
           <p:nvPr/>
         </p:nvSpPr>
@@ -16947,7 +17373,7 @@
       </p:sp>
       <p:sp>
         <p:nvSpPr>
-          <p:cNvPr id="9" name="Rectangle 8"/>
+          <p:cNvPr id="10" name="Rectangle 9"/>
           <p:cNvSpPr/>
           <p:nvPr/>
         </p:nvSpPr>
@@ -16991,7 +17417,7 @@
       </p:sp>
       <p:sp>
         <p:nvSpPr>
-          <p:cNvPr id="10" name="TextBox 9"/>
+          <p:cNvPr id="11" name="TextBox 10"/>
           <p:cNvSpPr txBox="1"/>
           <p:nvPr/>
         </p:nvSpPr>
@@ -17038,7 +17464,7 @@
       </p:sp>
       <p:sp>
         <p:nvSpPr>
-          <p:cNvPr id="11" name="TextBox 10"/>
+          <p:cNvPr id="12" name="TextBox 11"/>
           <p:cNvSpPr txBox="1"/>
           <p:nvPr/>
         </p:nvSpPr>
@@ -17109,7 +17535,7 @@
       </p:sp>
       <p:sp>
         <p:nvSpPr>
-          <p:cNvPr id="12" name="Rectangle 11"/>
+          <p:cNvPr id="13" name="Rectangle 12"/>
           <p:cNvSpPr/>
           <p:nvPr/>
         </p:nvSpPr>
@@ -17153,7 +17579,7 @@
       </p:sp>
       <p:sp>
         <p:nvSpPr>
-          <p:cNvPr id="13" name="TextBox 12"/>
+          <p:cNvPr id="14" name="TextBox 13"/>
           <p:cNvSpPr txBox="1"/>
           <p:nvPr/>
         </p:nvSpPr>
@@ -17200,7 +17626,7 @@
       </p:sp>
       <p:sp>
         <p:nvSpPr>
-          <p:cNvPr id="14" name="TextBox 13"/>
+          <p:cNvPr id="15" name="TextBox 14"/>
           <p:cNvSpPr txBox="1"/>
           <p:nvPr/>
         </p:nvSpPr>
@@ -17271,7 +17697,7 @@
       </p:sp>
       <p:sp>
         <p:nvSpPr>
-          <p:cNvPr id="15" name="Rectangle 14"/>
+          <p:cNvPr id="16" name="Rectangle 15"/>
           <p:cNvSpPr/>
           <p:nvPr/>
         </p:nvSpPr>
@@ -17315,7 +17741,7 @@
       </p:sp>
       <p:sp>
         <p:nvSpPr>
-          <p:cNvPr id="16" name="TextBox 15"/>
+          <p:cNvPr id="17" name="TextBox 16"/>
           <p:cNvSpPr txBox="1"/>
           <p:nvPr/>
         </p:nvSpPr>
@@ -17362,7 +17788,7 @@
       </p:sp>
       <p:sp>
         <p:nvSpPr>
-          <p:cNvPr id="17" name="TextBox 16"/>
+          <p:cNvPr id="18" name="TextBox 17"/>
           <p:cNvSpPr txBox="1"/>
           <p:nvPr/>
         </p:nvSpPr>
@@ -17433,7 +17859,7 @@
       </p:sp>
       <p:sp>
         <p:nvSpPr>
-          <p:cNvPr id="18" name="Rectangle 17"/>
+          <p:cNvPr id="19" name="Rectangle 18"/>
           <p:cNvSpPr/>
           <p:nvPr/>
         </p:nvSpPr>
@@ -17477,7 +17903,7 @@
       </p:sp>
       <p:sp>
         <p:nvSpPr>
-          <p:cNvPr id="19" name="TextBox 18"/>
+          <p:cNvPr id="20" name="TextBox 19"/>
           <p:cNvSpPr txBox="1"/>
           <p:nvPr/>
         </p:nvSpPr>
@@ -17524,7 +17950,7 @@
       </p:sp>
       <p:sp>
         <p:nvSpPr>
-          <p:cNvPr id="20" name="TextBox 19"/>
+          <p:cNvPr id="21" name="TextBox 20"/>
           <p:cNvSpPr txBox="1"/>
           <p:nvPr/>
         </p:nvSpPr>
@@ -17595,7 +18021,7 @@
       </p:sp>
       <p:sp>
         <p:nvSpPr>
-          <p:cNvPr id="21" name="Rectangle 20"/>
+          <p:cNvPr id="22" name="Rectangle 21"/>
           <p:cNvSpPr/>
           <p:nvPr/>
         </p:nvSpPr>
@@ -17639,7 +18065,7 @@
       </p:sp>
       <p:sp>
         <p:nvSpPr>
-          <p:cNvPr id="22" name="TextBox 21"/>
+          <p:cNvPr id="23" name="TextBox 22"/>
           <p:cNvSpPr txBox="1"/>
           <p:nvPr/>
         </p:nvSpPr>
@@ -17686,7 +18112,7 @@
       </p:sp>
       <p:sp>
         <p:nvSpPr>
-          <p:cNvPr id="23" name="TextBox 22"/>
+          <p:cNvPr id="24" name="TextBox 23"/>
           <p:cNvSpPr txBox="1"/>
           <p:nvPr/>
         </p:nvSpPr>
@@ -17757,7 +18183,7 @@
       </p:sp>
       <p:sp>
         <p:nvSpPr>
-          <p:cNvPr id="24" name="Rectangle 23"/>
+          <p:cNvPr id="25" name="Rectangle 24"/>
           <p:cNvSpPr/>
           <p:nvPr/>
         </p:nvSpPr>
@@ -17801,7 +18227,7 @@
       </p:sp>
       <p:sp>
         <p:nvSpPr>
-          <p:cNvPr id="25" name="TextBox 24"/>
+          <p:cNvPr id="26" name="TextBox 25"/>
           <p:cNvSpPr txBox="1"/>
           <p:nvPr/>
         </p:nvSpPr>
@@ -17848,7 +18274,7 @@
       </p:sp>
       <p:sp>
         <p:nvSpPr>
-          <p:cNvPr id="26" name="TextBox 25"/>
+          <p:cNvPr id="27" name="TextBox 26"/>
           <p:cNvSpPr txBox="1"/>
           <p:nvPr/>
         </p:nvSpPr>
@@ -17919,7 +18345,7 @@
       </p:sp>
       <p:sp>
         <p:nvSpPr>
-          <p:cNvPr id="27" name="Rectangle 26"/>
+          <p:cNvPr id="28" name="Rectangle 27"/>
           <p:cNvSpPr/>
           <p:nvPr/>
         </p:nvSpPr>
@@ -17963,7 +18389,7 @@
       </p:sp>
       <p:sp>
         <p:nvSpPr>
-          <p:cNvPr id="28" name="TextBox 27"/>
+          <p:cNvPr id="29" name="TextBox 28"/>
           <p:cNvSpPr txBox="1"/>
           <p:nvPr/>
         </p:nvSpPr>
@@ -18010,7 +18436,7 @@
       </p:sp>
       <p:sp>
         <p:nvSpPr>
-          <p:cNvPr id="29" name="TextBox 28"/>
+          <p:cNvPr id="30" name="TextBox 29"/>
           <p:cNvSpPr txBox="1"/>
           <p:nvPr/>
         </p:nvSpPr>
@@ -18081,7 +18507,7 @@
       </p:sp>
       <p:sp>
         <p:nvSpPr>
-          <p:cNvPr id="30" name="Rectangle 29"/>
+          <p:cNvPr id="31" name="Rectangle 30"/>
           <p:cNvSpPr/>
           <p:nvPr/>
         </p:nvSpPr>
@@ -18125,7 +18551,7 @@
       </p:sp>
       <p:sp>
         <p:nvSpPr>
-          <p:cNvPr id="31" name="TextBox 30"/>
+          <p:cNvPr id="32" name="TextBox 31"/>
           <p:cNvSpPr txBox="1"/>
           <p:nvPr/>
         </p:nvSpPr>
@@ -18172,7 +18598,7 @@
       </p:sp>
       <p:sp>
         <p:nvSpPr>
-          <p:cNvPr id="32" name="TextBox 31"/>
+          <p:cNvPr id="33" name="TextBox 32"/>
           <p:cNvSpPr txBox="1"/>
           <p:nvPr/>
         </p:nvSpPr>
@@ -18303,9 +18729,33 @@
           </a:p>
         </p:txBody>
       </p:sp>
-      <p:sp>
-        <p:nvSpPr>
-          <p:cNvPr id="3" name="TextBox 2"/>
+      <p:pic>
+        <p:nvPicPr>
+          <p:cNvPr id="3" name="college-logo" descr="logo-mark.png"/>
+          <p:cNvPicPr>
+            <a:picLocks noChangeAspect="1"/>
+          </p:cNvPicPr>
+          <p:nvPr/>
+        </p:nvPicPr>
+        <p:blipFill>
+          <a:blip r:embed="rId2"/>
+          <a:stretch>
+            <a:fillRect/>
+          </a:stretch>
+        </p:blipFill>
+        <p:spPr>
+          <a:xfrm>
+            <a:off x="11203333" y="6199632"/>
+            <a:ext cx="275129" cy="310896"/>
+          </a:xfrm>
+          <a:prstGeom prst="rect">
+            <a:avLst/>
+          </a:prstGeom>
+        </p:spPr>
+      </p:pic>
+      <p:sp>
+        <p:nvSpPr>
+          <p:cNvPr id="4" name="TextBox 3"/>
           <p:cNvSpPr txBox="1"/>
           <p:nvPr/>
         </p:nvSpPr>
@@ -18374,13 +18824,13 @@
       </p:sp>
       <p:sp>
         <p:nvSpPr>
-          <p:cNvPr id="4" name="TextBox 3"/>
+          <p:cNvPr id="5" name="TextBox 4"/>
           <p:cNvSpPr txBox="1"/>
           <p:nvPr/>
         </p:nvSpPr>
         <p:spPr>
           <a:xfrm>
-            <a:off x="8826703" y="6272784"/>
+            <a:off x="8240677" y="6272784"/>
             <a:ext cx="2651760" cy="219456"/>
           </a:xfrm>
           <a:prstGeom prst="rect">
@@ -18443,7 +18893,7 @@
       </p:sp>
       <p:sp>
         <p:nvSpPr>
-          <p:cNvPr id="5" name="TextBox 4"/>
+          <p:cNvPr id="6" name="TextBox 5"/>
           <p:cNvSpPr txBox="1"/>
           <p:nvPr/>
         </p:nvSpPr>
@@ -18490,7 +18940,7 @@
       </p:sp>
       <p:sp>
         <p:nvSpPr>
-          <p:cNvPr id="6" name="TextBox 5"/>
+          <p:cNvPr id="7" name="TextBox 6"/>
           <p:cNvSpPr txBox="1"/>
           <p:nvPr/>
         </p:nvSpPr>
@@ -18537,7 +18987,7 @@
       </p:sp>
       <p:sp>
         <p:nvSpPr>
-          <p:cNvPr id="7" name="Rectangle 6"/>
+          <p:cNvPr id="8" name="Rectangle 7"/>
           <p:cNvSpPr/>
           <p:nvPr/>
         </p:nvSpPr>
@@ -18581,7 +19031,7 @@
       </p:sp>
       <p:sp>
         <p:nvSpPr>
-          <p:cNvPr id="8" name="TextBox 7"/>
+          <p:cNvPr id="9" name="TextBox 8"/>
           <p:cNvSpPr txBox="1"/>
           <p:nvPr/>
         </p:nvSpPr>
@@ -18628,7 +19078,7 @@
       </p:sp>
       <p:sp>
         <p:nvSpPr>
-          <p:cNvPr id="9" name="Rectangle 8"/>
+          <p:cNvPr id="10" name="Rectangle 9"/>
           <p:cNvSpPr/>
           <p:nvPr/>
         </p:nvSpPr>
@@ -18672,7 +19122,7 @@
       </p:sp>
       <p:sp>
         <p:nvSpPr>
-          <p:cNvPr id="10" name="Oval 9"/>
+          <p:cNvPr id="11" name="Oval 10"/>
           <p:cNvSpPr/>
           <p:nvPr/>
         </p:nvSpPr>
@@ -18716,7 +19166,7 @@
       </p:sp>
       <p:sp>
         <p:nvSpPr>
-          <p:cNvPr id="11" name="TextBox 10"/>
+          <p:cNvPr id="12" name="TextBox 11"/>
           <p:cNvSpPr txBox="1"/>
           <p:nvPr/>
         </p:nvSpPr>
@@ -18763,7 +19213,7 @@
       </p:sp>
       <p:sp>
         <p:nvSpPr>
-          <p:cNvPr id="12" name="Rounded Rectangle 11"/>
+          <p:cNvPr id="13" name="Rounded Rectangle 12"/>
           <p:cNvSpPr/>
           <p:nvPr/>
         </p:nvSpPr>
@@ -18811,7 +19261,7 @@
       </p:sp>
       <p:sp>
         <p:nvSpPr>
-          <p:cNvPr id="13" name="TextBox 12"/>
+          <p:cNvPr id="14" name="TextBox 13"/>
           <p:cNvSpPr txBox="1"/>
           <p:nvPr/>
         </p:nvSpPr>
@@ -18858,7 +19308,7 @@
       </p:sp>
       <p:sp>
         <p:nvSpPr>
-          <p:cNvPr id="14" name="TextBox 13"/>
+          <p:cNvPr id="15" name="TextBox 14"/>
           <p:cNvSpPr txBox="1"/>
           <p:nvPr/>
         </p:nvSpPr>
@@ -18905,7 +19355,7 @@
       </p:sp>
       <p:sp>
         <p:nvSpPr>
-          <p:cNvPr id="15" name="Oval 14"/>
+          <p:cNvPr id="16" name="Oval 15"/>
           <p:cNvSpPr/>
           <p:nvPr/>
         </p:nvSpPr>
@@ -18949,7 +19399,7 @@
       </p:sp>
       <p:sp>
         <p:nvSpPr>
-          <p:cNvPr id="16" name="TextBox 15"/>
+          <p:cNvPr id="17" name="TextBox 16"/>
           <p:cNvSpPr txBox="1"/>
           <p:nvPr/>
         </p:nvSpPr>
@@ -18996,7 +19446,7 @@
       </p:sp>
       <p:sp>
         <p:nvSpPr>
-          <p:cNvPr id="17" name="Rounded Rectangle 16"/>
+          <p:cNvPr id="18" name="Rounded Rectangle 17"/>
           <p:cNvSpPr/>
           <p:nvPr/>
         </p:nvSpPr>
@@ -19044,7 +19494,7 @@
       </p:sp>
       <p:sp>
         <p:nvSpPr>
-          <p:cNvPr id="18" name="TextBox 17"/>
+          <p:cNvPr id="19" name="TextBox 18"/>
           <p:cNvSpPr txBox="1"/>
           <p:nvPr/>
         </p:nvSpPr>
@@ -19091,7 +19541,7 @@
       </p:sp>
       <p:sp>
         <p:nvSpPr>
-          <p:cNvPr id="19" name="TextBox 18"/>
+          <p:cNvPr id="20" name="TextBox 19"/>
           <p:cNvSpPr txBox="1"/>
           <p:nvPr/>
         </p:nvSpPr>
@@ -19138,7 +19588,7 @@
       </p:sp>
       <p:sp>
         <p:nvSpPr>
-          <p:cNvPr id="20" name="Oval 19"/>
+          <p:cNvPr id="21" name="Oval 20"/>
           <p:cNvSpPr/>
           <p:nvPr/>
         </p:nvSpPr>
@@ -19182,7 +19632,7 @@
       </p:sp>
       <p:sp>
         <p:nvSpPr>
-          <p:cNvPr id="21" name="TextBox 20"/>
+          <p:cNvPr id="22" name="TextBox 21"/>
           <p:cNvSpPr txBox="1"/>
           <p:nvPr/>
         </p:nvSpPr>
@@ -19229,7 +19679,7 @@
       </p:sp>
       <p:sp>
         <p:nvSpPr>
-          <p:cNvPr id="22" name="Rounded Rectangle 21"/>
+          <p:cNvPr id="23" name="Rounded Rectangle 22"/>
           <p:cNvSpPr/>
           <p:nvPr/>
         </p:nvSpPr>
@@ -19277,7 +19727,7 @@
       </p:sp>
       <p:sp>
         <p:nvSpPr>
-          <p:cNvPr id="23" name="TextBox 22"/>
+          <p:cNvPr id="24" name="TextBox 23"/>
           <p:cNvSpPr txBox="1"/>
           <p:nvPr/>
         </p:nvSpPr>
@@ -19324,7 +19774,7 @@
       </p:sp>
       <p:sp>
         <p:nvSpPr>
-          <p:cNvPr id="24" name="TextBox 23"/>
+          <p:cNvPr id="25" name="TextBox 24"/>
           <p:cNvSpPr txBox="1"/>
           <p:nvPr/>
         </p:nvSpPr>
@@ -19371,7 +19821,7 @@
       </p:sp>
       <p:sp>
         <p:nvSpPr>
-          <p:cNvPr id="25" name="Rounded Rectangle 24"/>
+          <p:cNvPr id="26" name="Rounded Rectangle 25"/>
           <p:cNvSpPr/>
           <p:nvPr/>
         </p:nvSpPr>
@@ -19438,7 +19888,7 @@
       </p:sp>
       <p:sp>
         <p:nvSpPr>
-          <p:cNvPr id="26" name="Rectangle 25"/>
+          <p:cNvPr id="27" name="Rectangle 26"/>
           <p:cNvSpPr/>
           <p:nvPr/>
         </p:nvSpPr>
@@ -19644,7 +20094,77 @@
       </p:sp>
       <p:sp>
         <p:nvSpPr>
-          <p:cNvPr id="5" name="TextBox 4"/>
+          <p:cNvPr id="5" name="logo-plate"/>
+          <p:cNvSpPr/>
+          <p:nvPr/>
+        </p:nvSpPr>
+        <p:spPr>
+          <a:xfrm>
+            <a:off x="9769160" y="502920"/>
+            <a:ext cx="1736734" cy="877824"/>
+          </a:xfrm>
+          <a:prstGeom prst="roundRect">
+            <a:avLst>
+              <a:gd name="adj" fmla="val 14000"/>
+            </a:avLst>
+          </a:prstGeom>
+          <a:solidFill>
+            <a:srgbClr val="FFFFFF"/>
+          </a:solidFill>
+          <a:ln>
+            <a:noFill/>
+          </a:ln>
+          <a:effectLst/>
+        </p:spPr>
+        <p:style>
+          <a:lnRef idx="1">
+            <a:schemeClr val="accent1"/>
+          </a:lnRef>
+          <a:fillRef idx="3">
+            <a:schemeClr val="accent1"/>
+          </a:fillRef>
+          <a:effectRef idx="2">
+            <a:schemeClr val="accent1"/>
+          </a:effectRef>
+          <a:fontRef idx="minor">
+            <a:schemeClr val="lt1"/>
+          </a:fontRef>
+        </p:style>
+        <p:txBody>
+          <a:bodyPr rtlCol="0" anchor="ctr" wrap="square"/>
+          <a:lstStyle/>
+          <a:p>
+            <a:pPr algn="ctr"/>
+          </a:p>
+        </p:txBody>
+      </p:sp>
+      <p:pic>
+        <p:nvPicPr>
+          <p:cNvPr id="6" name="college-logo" descr="logo-full.png"/>
+          <p:cNvPicPr>
+            <a:picLocks noChangeAspect="1"/>
+          </p:cNvPicPr>
+          <p:nvPr/>
+        </p:nvPicPr>
+        <p:blipFill>
+          <a:blip r:embed="rId2"/>
+          <a:stretch>
+            <a:fillRect/>
+          </a:stretch>
+        </p:blipFill>
+        <p:spPr>
+          <a:xfrm>
+            <a:off x="9888032" y="621792"/>
+            <a:ext cx="1498991" cy="640080"/>
+          </a:xfrm>
+          <a:prstGeom prst="rect">
+            <a:avLst/>
+          </a:prstGeom>
+        </p:spPr>
+      </p:pic>
+      <p:sp>
+        <p:nvSpPr>
+          <p:cNvPr id="7" name="TextBox 6"/>
           <p:cNvSpPr txBox="1"/>
           <p:nvPr/>
         </p:nvSpPr>
@@ -19691,7 +20211,7 @@
       </p:sp>
       <p:sp>
         <p:nvSpPr>
-          <p:cNvPr id="6" name="TextBox 5"/>
+          <p:cNvPr id="8" name="TextBox 7"/>
           <p:cNvSpPr txBox="1"/>
           <p:nvPr/>
         </p:nvSpPr>
@@ -19738,7 +20258,7 @@
       </p:sp>
       <p:sp>
         <p:nvSpPr>
-          <p:cNvPr id="7" name="Rectangle 6"/>
+          <p:cNvPr id="9" name="Rectangle 8"/>
           <p:cNvSpPr/>
           <p:nvPr/>
         </p:nvSpPr>
@@ -19782,7 +20302,7 @@
       </p:sp>
       <p:sp>
         <p:nvSpPr>
-          <p:cNvPr id="8" name="TextBox 7"/>
+          <p:cNvPr id="10" name="TextBox 9"/>
           <p:cNvSpPr txBox="1"/>
           <p:nvPr/>
         </p:nvSpPr>
@@ -19889,9 +20409,33 @@
           </a:p>
         </p:txBody>
       </p:sp>
-      <p:sp>
-        <p:nvSpPr>
-          <p:cNvPr id="3" name="TextBox 2"/>
+      <p:pic>
+        <p:nvPicPr>
+          <p:cNvPr id="3" name="college-logo" descr="logo-mark.png"/>
+          <p:cNvPicPr>
+            <a:picLocks noChangeAspect="1"/>
+          </p:cNvPicPr>
+          <p:nvPr/>
+        </p:nvPicPr>
+        <p:blipFill>
+          <a:blip r:embed="rId2"/>
+          <a:stretch>
+            <a:fillRect/>
+          </a:stretch>
+        </p:blipFill>
+        <p:spPr>
+          <a:xfrm>
+            <a:off x="11203333" y="6199632"/>
+            <a:ext cx="275129" cy="310896"/>
+          </a:xfrm>
+          <a:prstGeom prst="rect">
+            <a:avLst/>
+          </a:prstGeom>
+        </p:spPr>
+      </p:pic>
+      <p:sp>
+        <p:nvSpPr>
+          <p:cNvPr id="4" name="TextBox 3"/>
           <p:cNvSpPr txBox="1"/>
           <p:nvPr/>
         </p:nvSpPr>
@@ -19960,13 +20504,13 @@
       </p:sp>
       <p:sp>
         <p:nvSpPr>
-          <p:cNvPr id="4" name="TextBox 3"/>
+          <p:cNvPr id="5" name="TextBox 4"/>
           <p:cNvSpPr txBox="1"/>
           <p:nvPr/>
         </p:nvSpPr>
         <p:spPr>
           <a:xfrm>
-            <a:off x="8826703" y="6272784"/>
+            <a:off x="8240677" y="6272784"/>
             <a:ext cx="2651760" cy="219456"/>
           </a:xfrm>
           <a:prstGeom prst="rect">
@@ -20029,7 +20573,7 @@
       </p:sp>
       <p:sp>
         <p:nvSpPr>
-          <p:cNvPr id="5" name="TextBox 4"/>
+          <p:cNvPr id="6" name="TextBox 5"/>
           <p:cNvSpPr txBox="1"/>
           <p:nvPr/>
         </p:nvSpPr>
@@ -20076,7 +20620,7 @@
       </p:sp>
       <p:sp>
         <p:nvSpPr>
-          <p:cNvPr id="6" name="TextBox 5"/>
+          <p:cNvPr id="7" name="TextBox 6"/>
           <p:cNvSpPr txBox="1"/>
           <p:nvPr/>
         </p:nvSpPr>
@@ -20123,7 +20667,7 @@
       </p:sp>
       <p:sp>
         <p:nvSpPr>
-          <p:cNvPr id="7" name="Rectangle 6"/>
+          <p:cNvPr id="8" name="Rectangle 7"/>
           <p:cNvSpPr/>
           <p:nvPr/>
         </p:nvSpPr>
@@ -20167,7 +20711,7 @@
       </p:sp>
       <p:sp>
         <p:nvSpPr>
-          <p:cNvPr id="8" name="TextBox 7"/>
+          <p:cNvPr id="9" name="TextBox 8"/>
           <p:cNvSpPr txBox="1"/>
           <p:nvPr/>
         </p:nvSpPr>
@@ -20214,7 +20758,7 @@
       </p:sp>
       <p:sp>
         <p:nvSpPr>
-          <p:cNvPr id="9" name="Rounded Rectangle 8"/>
+          <p:cNvPr id="10" name="Rounded Rectangle 9"/>
           <p:cNvSpPr/>
           <p:nvPr/>
         </p:nvSpPr>
@@ -20268,7 +20812,7 @@
       </p:sp>
       <p:sp>
         <p:nvSpPr>
-          <p:cNvPr id="10" name="Rectangle 9"/>
+          <p:cNvPr id="11" name="Rectangle 10"/>
           <p:cNvSpPr/>
           <p:nvPr/>
         </p:nvSpPr>
@@ -20312,7 +20856,7 @@
       </p:sp>
       <p:sp>
         <p:nvSpPr>
-          <p:cNvPr id="11" name="Oval 10"/>
+          <p:cNvPr id="12" name="Oval 11"/>
           <p:cNvSpPr/>
           <p:nvPr/>
         </p:nvSpPr>
@@ -20356,7 +20900,7 @@
       </p:sp>
       <p:sp>
         <p:nvSpPr>
-          <p:cNvPr id="12" name="TextBox 11"/>
+          <p:cNvPr id="13" name="TextBox 12"/>
           <p:cNvSpPr txBox="1"/>
           <p:nvPr/>
         </p:nvSpPr>
@@ -20403,7 +20947,7 @@
       </p:sp>
       <p:sp>
         <p:nvSpPr>
-          <p:cNvPr id="13" name="TextBox 12"/>
+          <p:cNvPr id="14" name="TextBox 13"/>
           <p:cNvSpPr txBox="1"/>
           <p:nvPr/>
         </p:nvSpPr>
@@ -20474,7 +21018,7 @@
       </p:sp>
       <p:sp>
         <p:nvSpPr>
-          <p:cNvPr id="14" name="Rounded Rectangle 13"/>
+          <p:cNvPr id="15" name="Rounded Rectangle 14"/>
           <p:cNvSpPr/>
           <p:nvPr/>
         </p:nvSpPr>
@@ -20528,7 +21072,7 @@
       </p:sp>
       <p:sp>
         <p:nvSpPr>
-          <p:cNvPr id="15" name="Rectangle 14"/>
+          <p:cNvPr id="16" name="Rectangle 15"/>
           <p:cNvSpPr/>
           <p:nvPr/>
         </p:nvSpPr>
@@ -20572,7 +21116,7 @@
       </p:sp>
       <p:sp>
         <p:nvSpPr>
-          <p:cNvPr id="16" name="Oval 15"/>
+          <p:cNvPr id="17" name="Oval 16"/>
           <p:cNvSpPr/>
           <p:nvPr/>
         </p:nvSpPr>
@@ -20616,7 +21160,7 @@
       </p:sp>
       <p:sp>
         <p:nvSpPr>
-          <p:cNvPr id="17" name="TextBox 16"/>
+          <p:cNvPr id="18" name="TextBox 17"/>
           <p:cNvSpPr txBox="1"/>
           <p:nvPr/>
         </p:nvSpPr>
@@ -20663,7 +21207,7 @@
       </p:sp>
       <p:sp>
         <p:nvSpPr>
-          <p:cNvPr id="18" name="TextBox 17"/>
+          <p:cNvPr id="19" name="TextBox 18"/>
           <p:cNvSpPr txBox="1"/>
           <p:nvPr/>
         </p:nvSpPr>
@@ -20734,7 +21278,7 @@
       </p:sp>
       <p:sp>
         <p:nvSpPr>
-          <p:cNvPr id="19" name="Rounded Rectangle 18"/>
+          <p:cNvPr id="20" name="Rounded Rectangle 19"/>
           <p:cNvSpPr/>
           <p:nvPr/>
         </p:nvSpPr>
@@ -20788,7 +21332,7 @@
       </p:sp>
       <p:sp>
         <p:nvSpPr>
-          <p:cNvPr id="20" name="Rectangle 19"/>
+          <p:cNvPr id="21" name="Rectangle 20"/>
           <p:cNvSpPr/>
           <p:nvPr/>
         </p:nvSpPr>
@@ -20832,7 +21376,7 @@
       </p:sp>
       <p:sp>
         <p:nvSpPr>
-          <p:cNvPr id="21" name="Oval 20"/>
+          <p:cNvPr id="22" name="Oval 21"/>
           <p:cNvSpPr/>
           <p:nvPr/>
         </p:nvSpPr>
@@ -20876,7 +21420,7 @@
       </p:sp>
       <p:sp>
         <p:nvSpPr>
-          <p:cNvPr id="22" name="TextBox 21"/>
+          <p:cNvPr id="23" name="TextBox 22"/>
           <p:cNvSpPr txBox="1"/>
           <p:nvPr/>
         </p:nvSpPr>
@@ -20923,7 +21467,7 @@
       </p:sp>
       <p:sp>
         <p:nvSpPr>
-          <p:cNvPr id="23" name="TextBox 22"/>
+          <p:cNvPr id="24" name="TextBox 23"/>
           <p:cNvSpPr txBox="1"/>
           <p:nvPr/>
         </p:nvSpPr>
@@ -20994,7 +21538,7 @@
       </p:sp>
       <p:sp>
         <p:nvSpPr>
-          <p:cNvPr id="24" name="Rounded Rectangle 23"/>
+          <p:cNvPr id="25" name="Rounded Rectangle 24"/>
           <p:cNvSpPr/>
           <p:nvPr/>
         </p:nvSpPr>
@@ -21048,7 +21592,7 @@
       </p:sp>
       <p:sp>
         <p:nvSpPr>
-          <p:cNvPr id="25" name="Rectangle 24"/>
+          <p:cNvPr id="26" name="Rectangle 25"/>
           <p:cNvSpPr/>
           <p:nvPr/>
         </p:nvSpPr>
@@ -21092,7 +21636,7 @@
       </p:sp>
       <p:sp>
         <p:nvSpPr>
-          <p:cNvPr id="26" name="Oval 25"/>
+          <p:cNvPr id="27" name="Oval 26"/>
           <p:cNvSpPr/>
           <p:nvPr/>
         </p:nvSpPr>
@@ -21136,7 +21680,7 @@
       </p:sp>
       <p:sp>
         <p:nvSpPr>
-          <p:cNvPr id="27" name="TextBox 26"/>
+          <p:cNvPr id="28" name="TextBox 27"/>
           <p:cNvSpPr txBox="1"/>
           <p:nvPr/>
         </p:nvSpPr>
@@ -21183,7 +21727,7 @@
       </p:sp>
       <p:sp>
         <p:nvSpPr>
-          <p:cNvPr id="28" name="TextBox 27"/>
+          <p:cNvPr id="29" name="TextBox 28"/>
           <p:cNvSpPr txBox="1"/>
           <p:nvPr/>
         </p:nvSpPr>
@@ -21254,7 +21798,7 @@
       </p:sp>
       <p:sp>
         <p:nvSpPr>
-          <p:cNvPr id="29" name="Rounded Rectangle 28"/>
+          <p:cNvPr id="30" name="Rounded Rectangle 29"/>
           <p:cNvSpPr/>
           <p:nvPr/>
         </p:nvSpPr>
@@ -21308,7 +21852,7 @@
       </p:sp>
       <p:sp>
         <p:nvSpPr>
-          <p:cNvPr id="30" name="Rectangle 29"/>
+          <p:cNvPr id="31" name="Rectangle 30"/>
           <p:cNvSpPr/>
           <p:nvPr/>
         </p:nvSpPr>
@@ -21352,7 +21896,7 @@
       </p:sp>
       <p:sp>
         <p:nvSpPr>
-          <p:cNvPr id="31" name="Oval 30"/>
+          <p:cNvPr id="32" name="Oval 31"/>
           <p:cNvSpPr/>
           <p:nvPr/>
         </p:nvSpPr>
@@ -21396,7 +21940,7 @@
       </p:sp>
       <p:sp>
         <p:nvSpPr>
-          <p:cNvPr id="32" name="TextBox 31"/>
+          <p:cNvPr id="33" name="TextBox 32"/>
           <p:cNvSpPr txBox="1"/>
           <p:nvPr/>
         </p:nvSpPr>
@@ -21443,7 +21987,7 @@
       </p:sp>
       <p:sp>
         <p:nvSpPr>
-          <p:cNvPr id="33" name="TextBox 32"/>
+          <p:cNvPr id="34" name="TextBox 33"/>
           <p:cNvSpPr txBox="1"/>
           <p:nvPr/>
         </p:nvSpPr>
@@ -21514,7 +22058,7 @@
       </p:sp>
       <p:sp>
         <p:nvSpPr>
-          <p:cNvPr id="34" name="Rounded Rectangle 33"/>
+          <p:cNvPr id="35" name="Rounded Rectangle 34"/>
           <p:cNvSpPr/>
           <p:nvPr/>
         </p:nvSpPr>
@@ -21568,7 +22112,7 @@
       </p:sp>
       <p:sp>
         <p:nvSpPr>
-          <p:cNvPr id="35" name="Rectangle 34"/>
+          <p:cNvPr id="36" name="Rectangle 35"/>
           <p:cNvSpPr/>
           <p:nvPr/>
         </p:nvSpPr>
@@ -21612,7 +22156,7 @@
       </p:sp>
       <p:sp>
         <p:nvSpPr>
-          <p:cNvPr id="36" name="Oval 35"/>
+          <p:cNvPr id="37" name="Oval 36"/>
           <p:cNvSpPr/>
           <p:nvPr/>
         </p:nvSpPr>
@@ -21656,7 +22200,7 @@
       </p:sp>
       <p:sp>
         <p:nvSpPr>
-          <p:cNvPr id="37" name="TextBox 36"/>
+          <p:cNvPr id="38" name="TextBox 37"/>
           <p:cNvSpPr txBox="1"/>
           <p:nvPr/>
         </p:nvSpPr>
@@ -21703,7 +22247,7 @@
       </p:sp>
       <p:sp>
         <p:nvSpPr>
-          <p:cNvPr id="38" name="TextBox 37"/>
+          <p:cNvPr id="39" name="TextBox 38"/>
           <p:cNvSpPr txBox="1"/>
           <p:nvPr/>
         </p:nvSpPr>
@@ -22284,7 +22828,77 @@
       </p:sp>
       <p:sp>
         <p:nvSpPr>
-          <p:cNvPr id="11" name="Rectangle 10"/>
+          <p:cNvPr id="11" name="logo-plate"/>
+          <p:cNvSpPr/>
+          <p:nvPr/>
+        </p:nvSpPr>
+        <p:spPr>
+          <a:xfrm>
+            <a:off x="9233806" y="539496"/>
+            <a:ext cx="2272088" cy="1106424"/>
+          </a:xfrm>
+          <a:prstGeom prst="roundRect">
+            <a:avLst>
+              <a:gd name="adj" fmla="val 14000"/>
+            </a:avLst>
+          </a:prstGeom>
+          <a:solidFill>
+            <a:srgbClr val="FFFFFF"/>
+          </a:solidFill>
+          <a:ln>
+            <a:noFill/>
+          </a:ln>
+          <a:effectLst/>
+        </p:spPr>
+        <p:style>
+          <a:lnRef idx="1">
+            <a:schemeClr val="accent1"/>
+          </a:lnRef>
+          <a:fillRef idx="3">
+            <a:schemeClr val="accent1"/>
+          </a:fillRef>
+          <a:effectRef idx="2">
+            <a:schemeClr val="accent1"/>
+          </a:effectRef>
+          <a:fontRef idx="minor">
+            <a:schemeClr val="lt1"/>
+          </a:fontRef>
+        </p:style>
+        <p:txBody>
+          <a:bodyPr rtlCol="0" anchor="ctr" wrap="square"/>
+          <a:lstStyle/>
+          <a:p>
+            <a:pPr algn="ctr"/>
+          </a:p>
+        </p:txBody>
+      </p:sp>
+      <p:pic>
+        <p:nvPicPr>
+          <p:cNvPr id="12" name="college-logo" descr="logo-full.png"/>
+          <p:cNvPicPr>
+            <a:picLocks noChangeAspect="1"/>
+          </p:cNvPicPr>
+          <p:nvPr/>
+        </p:nvPicPr>
+        <p:blipFill>
+          <a:blip r:embed="rId2"/>
+          <a:stretch>
+            <a:fillRect/>
+          </a:stretch>
+        </p:blipFill>
+        <p:spPr>
+          <a:xfrm>
+            <a:off x="9352678" y="658368"/>
+            <a:ext cx="2034345" cy="868680"/>
+          </a:xfrm>
+          <a:prstGeom prst="rect">
+            <a:avLst/>
+          </a:prstGeom>
+        </p:spPr>
+      </p:pic>
+      <p:sp>
+        <p:nvSpPr>
+          <p:cNvPr id="13" name="Rectangle 12"/>
           <p:cNvSpPr/>
           <p:nvPr/>
         </p:nvSpPr>
@@ -22328,7 +22942,7 @@
       </p:sp>
       <p:sp>
         <p:nvSpPr>
-          <p:cNvPr id="12" name="TextBox 11"/>
+          <p:cNvPr id="14" name="TextBox 13"/>
           <p:cNvSpPr txBox="1"/>
           <p:nvPr/>
         </p:nvSpPr>
@@ -22855,6 +23469,76 @@
           </a:p>
         </p:txBody>
       </p:sp>
+      <p:sp>
+        <p:nvSpPr>
+          <p:cNvPr id="11" name="logo-plate"/>
+          <p:cNvSpPr/>
+          <p:nvPr/>
+        </p:nvSpPr>
+        <p:spPr>
+          <a:xfrm>
+            <a:off x="9512190" y="539496"/>
+            <a:ext cx="1993704" cy="987552"/>
+          </a:xfrm>
+          <a:prstGeom prst="roundRect">
+            <a:avLst>
+              <a:gd name="adj" fmla="val 14000"/>
+            </a:avLst>
+          </a:prstGeom>
+          <a:solidFill>
+            <a:srgbClr val="FFFFFF"/>
+          </a:solidFill>
+          <a:ln>
+            <a:noFill/>
+          </a:ln>
+          <a:effectLst/>
+        </p:spPr>
+        <p:style>
+          <a:lnRef idx="1">
+            <a:schemeClr val="accent1"/>
+          </a:lnRef>
+          <a:fillRef idx="3">
+            <a:schemeClr val="accent1"/>
+          </a:fillRef>
+          <a:effectRef idx="2">
+            <a:schemeClr val="accent1"/>
+          </a:effectRef>
+          <a:fontRef idx="minor">
+            <a:schemeClr val="lt1"/>
+          </a:fontRef>
+        </p:style>
+        <p:txBody>
+          <a:bodyPr rtlCol="0" anchor="ctr" wrap="square"/>
+          <a:lstStyle/>
+          <a:p>
+            <a:pPr algn="ctr"/>
+          </a:p>
+        </p:txBody>
+      </p:sp>
+      <p:pic>
+        <p:nvPicPr>
+          <p:cNvPr id="12" name="college-logo" descr="logo-full.png"/>
+          <p:cNvPicPr>
+            <a:picLocks noChangeAspect="1"/>
+          </p:cNvPicPr>
+          <p:nvPr/>
+        </p:nvPicPr>
+        <p:blipFill>
+          <a:blip r:embed="rId2"/>
+          <a:stretch>
+            <a:fillRect/>
+          </a:stretch>
+        </p:blipFill>
+        <p:spPr>
+          <a:xfrm>
+            <a:off x="9631062" y="658368"/>
+            <a:ext cx="1755961" cy="749808"/>
+          </a:xfrm>
+          <a:prstGeom prst="rect">
+            <a:avLst/>
+          </a:prstGeom>
+        </p:spPr>
+      </p:pic>
     </p:spTree>
   </p:cSld>
   <p:clrMapOvr>
@@ -22917,9 +23601,33 @@
           </a:p>
         </p:txBody>
       </p:sp>
-      <p:sp>
-        <p:nvSpPr>
-          <p:cNvPr id="3" name="TextBox 2"/>
+      <p:pic>
+        <p:nvPicPr>
+          <p:cNvPr id="3" name="college-logo" descr="logo-mark.png"/>
+          <p:cNvPicPr>
+            <a:picLocks noChangeAspect="1"/>
+          </p:cNvPicPr>
+          <p:nvPr/>
+        </p:nvPicPr>
+        <p:blipFill>
+          <a:blip r:embed="rId2"/>
+          <a:stretch>
+            <a:fillRect/>
+          </a:stretch>
+        </p:blipFill>
+        <p:spPr>
+          <a:xfrm>
+            <a:off x="11203333" y="6199632"/>
+            <a:ext cx="275129" cy="310896"/>
+          </a:xfrm>
+          <a:prstGeom prst="rect">
+            <a:avLst/>
+          </a:prstGeom>
+        </p:spPr>
+      </p:pic>
+      <p:sp>
+        <p:nvSpPr>
+          <p:cNvPr id="4" name="TextBox 3"/>
           <p:cNvSpPr txBox="1"/>
           <p:nvPr/>
         </p:nvSpPr>
@@ -22988,13 +23696,13 @@
       </p:sp>
       <p:sp>
         <p:nvSpPr>
-          <p:cNvPr id="4" name="TextBox 3"/>
+          <p:cNvPr id="5" name="TextBox 4"/>
           <p:cNvSpPr txBox="1"/>
           <p:nvPr/>
         </p:nvSpPr>
         <p:spPr>
           <a:xfrm>
-            <a:off x="8826703" y="6272784"/>
+            <a:off x="8240677" y="6272784"/>
             <a:ext cx="2651760" cy="219456"/>
           </a:xfrm>
           <a:prstGeom prst="rect">
@@ -23057,7 +23765,7 @@
       </p:sp>
       <p:sp>
         <p:nvSpPr>
-          <p:cNvPr id="5" name="TextBox 4"/>
+          <p:cNvPr id="6" name="TextBox 5"/>
           <p:cNvSpPr txBox="1"/>
           <p:nvPr/>
         </p:nvSpPr>
@@ -23104,7 +23812,7 @@
       </p:sp>
       <p:sp>
         <p:nvSpPr>
-          <p:cNvPr id="6" name="TextBox 5"/>
+          <p:cNvPr id="7" name="TextBox 6"/>
           <p:cNvSpPr txBox="1"/>
           <p:nvPr/>
         </p:nvSpPr>
@@ -23151,7 +23859,7 @@
       </p:sp>
       <p:sp>
         <p:nvSpPr>
-          <p:cNvPr id="7" name="Rectangle 6"/>
+          <p:cNvPr id="8" name="Rectangle 7"/>
           <p:cNvSpPr/>
           <p:nvPr/>
         </p:nvSpPr>
@@ -23195,7 +23903,7 @@
       </p:sp>
       <p:sp>
         <p:nvSpPr>
-          <p:cNvPr id="8" name="TextBox 7"/>
+          <p:cNvPr id="9" name="TextBox 8"/>
           <p:cNvSpPr txBox="1"/>
           <p:nvPr/>
         </p:nvSpPr>
@@ -23242,7 +23950,7 @@
       </p:sp>
       <p:sp>
         <p:nvSpPr>
-          <p:cNvPr id="9" name="Rounded Rectangle 8"/>
+          <p:cNvPr id="10" name="Rounded Rectangle 9"/>
           <p:cNvSpPr/>
           <p:nvPr/>
         </p:nvSpPr>
@@ -23288,7 +23996,7 @@
       </p:sp>
       <p:sp>
         <p:nvSpPr>
-          <p:cNvPr id="10" name="Rectangle 9"/>
+          <p:cNvPr id="11" name="Rectangle 10"/>
           <p:cNvSpPr/>
           <p:nvPr/>
         </p:nvSpPr>
@@ -23332,7 +24040,7 @@
       </p:sp>
       <p:sp>
         <p:nvSpPr>
-          <p:cNvPr id="11" name="TextBox 10"/>
+          <p:cNvPr id="12" name="TextBox 11"/>
           <p:cNvSpPr txBox="1"/>
           <p:nvPr/>
         </p:nvSpPr>
@@ -23379,7 +24087,7 @@
       </p:sp>
       <p:sp>
         <p:nvSpPr>
-          <p:cNvPr id="12" name="TextBox 11"/>
+          <p:cNvPr id="13" name="TextBox 12"/>
           <p:cNvSpPr txBox="1"/>
           <p:nvPr/>
         </p:nvSpPr>
@@ -23426,7 +24134,7 @@
       </p:sp>
       <p:sp>
         <p:nvSpPr>
-          <p:cNvPr id="13" name="Rounded Rectangle 12"/>
+          <p:cNvPr id="14" name="Rounded Rectangle 13"/>
           <p:cNvSpPr/>
           <p:nvPr/>
         </p:nvSpPr>
@@ -23472,7 +24180,7 @@
       </p:sp>
       <p:sp>
         <p:nvSpPr>
-          <p:cNvPr id="14" name="Rectangle 13"/>
+          <p:cNvPr id="15" name="Rectangle 14"/>
           <p:cNvSpPr/>
           <p:nvPr/>
         </p:nvSpPr>
@@ -23516,7 +24224,7 @@
       </p:sp>
       <p:sp>
         <p:nvSpPr>
-          <p:cNvPr id="15" name="TextBox 14"/>
+          <p:cNvPr id="16" name="TextBox 15"/>
           <p:cNvSpPr txBox="1"/>
           <p:nvPr/>
         </p:nvSpPr>
@@ -23563,7 +24271,7 @@
       </p:sp>
       <p:sp>
         <p:nvSpPr>
-          <p:cNvPr id="16" name="TextBox 15"/>
+          <p:cNvPr id="17" name="TextBox 16"/>
           <p:cNvSpPr txBox="1"/>
           <p:nvPr/>
         </p:nvSpPr>
@@ -23610,7 +24318,7 @@
       </p:sp>
       <p:sp>
         <p:nvSpPr>
-          <p:cNvPr id="17" name="Rounded Rectangle 16"/>
+          <p:cNvPr id="18" name="Rounded Rectangle 17"/>
           <p:cNvSpPr/>
           <p:nvPr/>
         </p:nvSpPr>
@@ -23656,7 +24364,7 @@
       </p:sp>
       <p:sp>
         <p:nvSpPr>
-          <p:cNvPr id="18" name="Rectangle 17"/>
+          <p:cNvPr id="19" name="Rectangle 18"/>
           <p:cNvSpPr/>
           <p:nvPr/>
         </p:nvSpPr>
@@ -23700,7 +24408,7 @@
       </p:sp>
       <p:sp>
         <p:nvSpPr>
-          <p:cNvPr id="19" name="TextBox 18"/>
+          <p:cNvPr id="20" name="TextBox 19"/>
           <p:cNvSpPr txBox="1"/>
           <p:nvPr/>
         </p:nvSpPr>
@@ -23747,7 +24455,7 @@
       </p:sp>
       <p:sp>
         <p:nvSpPr>
-          <p:cNvPr id="20" name="TextBox 19"/>
+          <p:cNvPr id="21" name="TextBox 20"/>
           <p:cNvSpPr txBox="1"/>
           <p:nvPr/>
         </p:nvSpPr>
@@ -23794,7 +24502,7 @@
       </p:sp>
       <p:sp>
         <p:nvSpPr>
-          <p:cNvPr id="21" name="Rounded Rectangle 20"/>
+          <p:cNvPr id="22" name="Rounded Rectangle 21"/>
           <p:cNvSpPr/>
           <p:nvPr/>
         </p:nvSpPr>
@@ -23840,7 +24548,7 @@
       </p:sp>
       <p:sp>
         <p:nvSpPr>
-          <p:cNvPr id="22" name="Rectangle 21"/>
+          <p:cNvPr id="23" name="Rectangle 22"/>
           <p:cNvSpPr/>
           <p:nvPr/>
         </p:nvSpPr>
@@ -23884,7 +24592,7 @@
       </p:sp>
       <p:sp>
         <p:nvSpPr>
-          <p:cNvPr id="23" name="TextBox 22"/>
+          <p:cNvPr id="24" name="TextBox 23"/>
           <p:cNvSpPr txBox="1"/>
           <p:nvPr/>
         </p:nvSpPr>
@@ -23931,7 +24639,7 @@
       </p:sp>
       <p:sp>
         <p:nvSpPr>
-          <p:cNvPr id="24" name="TextBox 23"/>
+          <p:cNvPr id="25" name="TextBox 24"/>
           <p:cNvSpPr txBox="1"/>
           <p:nvPr/>
         </p:nvSpPr>
@@ -24038,9 +24746,33 @@
           </a:p>
         </p:txBody>
       </p:sp>
-      <p:sp>
-        <p:nvSpPr>
-          <p:cNvPr id="3" name="TextBox 2"/>
+      <p:pic>
+        <p:nvPicPr>
+          <p:cNvPr id="3" name="college-logo" descr="logo-mark.png"/>
+          <p:cNvPicPr>
+            <a:picLocks noChangeAspect="1"/>
+          </p:cNvPicPr>
+          <p:nvPr/>
+        </p:nvPicPr>
+        <p:blipFill>
+          <a:blip r:embed="rId2"/>
+          <a:stretch>
+            <a:fillRect/>
+          </a:stretch>
+        </p:blipFill>
+        <p:spPr>
+          <a:xfrm>
+            <a:off x="11203333" y="6199632"/>
+            <a:ext cx="275129" cy="310896"/>
+          </a:xfrm>
+          <a:prstGeom prst="rect">
+            <a:avLst/>
+          </a:prstGeom>
+        </p:spPr>
+      </p:pic>
+      <p:sp>
+        <p:nvSpPr>
+          <p:cNvPr id="4" name="TextBox 3"/>
           <p:cNvSpPr txBox="1"/>
           <p:nvPr/>
         </p:nvSpPr>
@@ -24109,13 +24841,13 @@
       </p:sp>
       <p:sp>
         <p:nvSpPr>
-          <p:cNvPr id="4" name="TextBox 3"/>
+          <p:cNvPr id="5" name="TextBox 4"/>
           <p:cNvSpPr txBox="1"/>
           <p:nvPr/>
         </p:nvSpPr>
         <p:spPr>
           <a:xfrm>
-            <a:off x="8826703" y="6272784"/>
+            <a:off x="8240677" y="6272784"/>
             <a:ext cx="2651760" cy="219456"/>
           </a:xfrm>
           <a:prstGeom prst="rect">
@@ -24178,7 +24910,7 @@
       </p:sp>
       <p:sp>
         <p:nvSpPr>
-          <p:cNvPr id="5" name="TextBox 4"/>
+          <p:cNvPr id="6" name="TextBox 5"/>
           <p:cNvSpPr txBox="1"/>
           <p:nvPr/>
         </p:nvSpPr>
@@ -24225,7 +24957,7 @@
       </p:sp>
       <p:sp>
         <p:nvSpPr>
-          <p:cNvPr id="6" name="TextBox 5"/>
+          <p:cNvPr id="7" name="TextBox 6"/>
           <p:cNvSpPr txBox="1"/>
           <p:nvPr/>
         </p:nvSpPr>
@@ -24272,7 +25004,7 @@
       </p:sp>
       <p:sp>
         <p:nvSpPr>
-          <p:cNvPr id="7" name="Rectangle 6"/>
+          <p:cNvPr id="8" name="Rectangle 7"/>
           <p:cNvSpPr/>
           <p:nvPr/>
         </p:nvSpPr>
@@ -24316,7 +25048,7 @@
       </p:sp>
       <p:sp>
         <p:nvSpPr>
-          <p:cNvPr id="8" name="Rounded Rectangle 7"/>
+          <p:cNvPr id="9" name="Rounded Rectangle 8"/>
           <p:cNvSpPr/>
           <p:nvPr/>
         </p:nvSpPr>
@@ -24370,7 +25102,7 @@
       </p:sp>
       <p:sp>
         <p:nvSpPr>
-          <p:cNvPr id="9" name="Rectangle 8"/>
+          <p:cNvPr id="10" name="Rectangle 9"/>
           <p:cNvSpPr/>
           <p:nvPr/>
         </p:nvSpPr>
@@ -24414,7 +25146,7 @@
       </p:sp>
       <p:sp>
         <p:nvSpPr>
-          <p:cNvPr id="10" name="Rounded Rectangle 9"/>
+          <p:cNvPr id="11" name="Rounded Rectangle 10"/>
           <p:cNvSpPr/>
           <p:nvPr/>
         </p:nvSpPr>
@@ -24481,7 +25213,7 @@
       </p:sp>
       <p:sp>
         <p:nvSpPr>
-          <p:cNvPr id="11" name="TextBox 10"/>
+          <p:cNvPr id="12" name="TextBox 11"/>
           <p:cNvSpPr txBox="1"/>
           <p:nvPr/>
         </p:nvSpPr>
@@ -24528,7 +25260,7 @@
       </p:sp>
       <p:sp>
         <p:nvSpPr>
-          <p:cNvPr id="12" name="Rectangle 11"/>
+          <p:cNvPr id="13" name="Rectangle 12"/>
           <p:cNvSpPr/>
           <p:nvPr/>
         </p:nvSpPr>
@@ -24572,7 +25304,7 @@
       </p:sp>
       <p:sp>
         <p:nvSpPr>
-          <p:cNvPr id="13" name="Rounded Rectangle 12"/>
+          <p:cNvPr id="14" name="Rounded Rectangle 13"/>
           <p:cNvSpPr/>
           <p:nvPr/>
         </p:nvSpPr>
@@ -24618,7 +25350,7 @@
       </p:sp>
       <p:sp>
         <p:nvSpPr>
-          <p:cNvPr id="14" name="TextBox 13"/>
+          <p:cNvPr id="15" name="TextBox 14"/>
           <p:cNvSpPr txBox="1"/>
           <p:nvPr/>
         </p:nvSpPr>
@@ -24665,7 +25397,7 @@
       </p:sp>
       <p:sp>
         <p:nvSpPr>
-          <p:cNvPr id="15" name="Rounded Rectangle 14"/>
+          <p:cNvPr id="16" name="Rounded Rectangle 15"/>
           <p:cNvSpPr/>
           <p:nvPr/>
         </p:nvSpPr>
@@ -24711,7 +25443,7 @@
       </p:sp>
       <p:sp>
         <p:nvSpPr>
-          <p:cNvPr id="16" name="TextBox 15"/>
+          <p:cNvPr id="17" name="TextBox 16"/>
           <p:cNvSpPr txBox="1"/>
           <p:nvPr/>
         </p:nvSpPr>
@@ -24758,7 +25490,7 @@
       </p:sp>
       <p:sp>
         <p:nvSpPr>
-          <p:cNvPr id="17" name="Rounded Rectangle 16"/>
+          <p:cNvPr id="18" name="Rounded Rectangle 17"/>
           <p:cNvSpPr/>
           <p:nvPr/>
         </p:nvSpPr>
@@ -24804,7 +25536,7 @@
       </p:sp>
       <p:sp>
         <p:nvSpPr>
-          <p:cNvPr id="18" name="TextBox 17"/>
+          <p:cNvPr id="19" name="TextBox 18"/>
           <p:cNvSpPr txBox="1"/>
           <p:nvPr/>
         </p:nvSpPr>
@@ -24851,7 +25583,7 @@
       </p:sp>
       <p:sp>
         <p:nvSpPr>
-          <p:cNvPr id="19" name="Rounded Rectangle 18"/>
+          <p:cNvPr id="20" name="Rounded Rectangle 19"/>
           <p:cNvSpPr/>
           <p:nvPr/>
         </p:nvSpPr>
@@ -24897,7 +25629,7 @@
       </p:sp>
       <p:sp>
         <p:nvSpPr>
-          <p:cNvPr id="20" name="TextBox 19"/>
+          <p:cNvPr id="21" name="TextBox 20"/>
           <p:cNvSpPr txBox="1"/>
           <p:nvPr/>
         </p:nvSpPr>
@@ -24944,7 +25676,7 @@
       </p:sp>
       <p:sp>
         <p:nvSpPr>
-          <p:cNvPr id="21" name="Rounded Rectangle 20"/>
+          <p:cNvPr id="22" name="Rounded Rectangle 21"/>
           <p:cNvSpPr/>
           <p:nvPr/>
         </p:nvSpPr>
@@ -24990,7 +25722,7 @@
       </p:sp>
       <p:sp>
         <p:nvSpPr>
-          <p:cNvPr id="22" name="TextBox 21"/>
+          <p:cNvPr id="23" name="TextBox 22"/>
           <p:cNvSpPr txBox="1"/>
           <p:nvPr/>
         </p:nvSpPr>
@@ -25037,7 +25769,7 @@
       </p:sp>
       <p:sp>
         <p:nvSpPr>
-          <p:cNvPr id="23" name="Rounded Rectangle 22"/>
+          <p:cNvPr id="24" name="Rounded Rectangle 23"/>
           <p:cNvSpPr/>
           <p:nvPr/>
         </p:nvSpPr>
@@ -25091,7 +25823,7 @@
       </p:sp>
       <p:sp>
         <p:nvSpPr>
-          <p:cNvPr id="24" name="Rectangle 23"/>
+          <p:cNvPr id="25" name="Rectangle 24"/>
           <p:cNvSpPr/>
           <p:nvPr/>
         </p:nvSpPr>
@@ -25135,7 +25867,7 @@
       </p:sp>
       <p:sp>
         <p:nvSpPr>
-          <p:cNvPr id="25" name="Rounded Rectangle 24"/>
+          <p:cNvPr id="26" name="Rounded Rectangle 25"/>
           <p:cNvSpPr/>
           <p:nvPr/>
         </p:nvSpPr>
@@ -25202,7 +25934,7 @@
       </p:sp>
       <p:sp>
         <p:nvSpPr>
-          <p:cNvPr id="26" name="TextBox 25"/>
+          <p:cNvPr id="27" name="TextBox 26"/>
           <p:cNvSpPr txBox="1"/>
           <p:nvPr/>
         </p:nvSpPr>
@@ -25249,7 +25981,7 @@
       </p:sp>
       <p:sp>
         <p:nvSpPr>
-          <p:cNvPr id="27" name="Rectangle 26"/>
+          <p:cNvPr id="28" name="Rectangle 27"/>
           <p:cNvSpPr/>
           <p:nvPr/>
         </p:nvSpPr>
@@ -25293,7 +26025,7 @@
       </p:sp>
       <p:sp>
         <p:nvSpPr>
-          <p:cNvPr id="28" name="Rounded Rectangle 27"/>
+          <p:cNvPr id="29" name="Rounded Rectangle 28"/>
           <p:cNvSpPr/>
           <p:nvPr/>
         </p:nvSpPr>
@@ -25339,7 +26071,7 @@
       </p:sp>
       <p:sp>
         <p:nvSpPr>
-          <p:cNvPr id="29" name="TextBox 28"/>
+          <p:cNvPr id="30" name="TextBox 29"/>
           <p:cNvSpPr txBox="1"/>
           <p:nvPr/>
         </p:nvSpPr>
@@ -25386,7 +26118,7 @@
       </p:sp>
       <p:sp>
         <p:nvSpPr>
-          <p:cNvPr id="30" name="Rounded Rectangle 29"/>
+          <p:cNvPr id="31" name="Rounded Rectangle 30"/>
           <p:cNvSpPr/>
           <p:nvPr/>
         </p:nvSpPr>
@@ -25432,7 +26164,7 @@
       </p:sp>
       <p:sp>
         <p:nvSpPr>
-          <p:cNvPr id="31" name="TextBox 30"/>
+          <p:cNvPr id="32" name="TextBox 31"/>
           <p:cNvSpPr txBox="1"/>
           <p:nvPr/>
         </p:nvSpPr>
@@ -25479,7 +26211,7 @@
       </p:sp>
       <p:sp>
         <p:nvSpPr>
-          <p:cNvPr id="32" name="Rounded Rectangle 31"/>
+          <p:cNvPr id="33" name="Rounded Rectangle 32"/>
           <p:cNvSpPr/>
           <p:nvPr/>
         </p:nvSpPr>
@@ -25525,7 +26257,7 @@
       </p:sp>
       <p:sp>
         <p:nvSpPr>
-          <p:cNvPr id="33" name="TextBox 32"/>
+          <p:cNvPr id="34" name="TextBox 33"/>
           <p:cNvSpPr txBox="1"/>
           <p:nvPr/>
         </p:nvSpPr>
@@ -25572,7 +26304,7 @@
       </p:sp>
       <p:sp>
         <p:nvSpPr>
-          <p:cNvPr id="34" name="Rounded Rectangle 33"/>
+          <p:cNvPr id="35" name="Rounded Rectangle 34"/>
           <p:cNvSpPr/>
           <p:nvPr/>
         </p:nvSpPr>
@@ -25618,7 +26350,7 @@
       </p:sp>
       <p:sp>
         <p:nvSpPr>
-          <p:cNvPr id="35" name="TextBox 34"/>
+          <p:cNvPr id="36" name="TextBox 35"/>
           <p:cNvSpPr txBox="1"/>
           <p:nvPr/>
         </p:nvSpPr>
@@ -25665,7 +26397,7 @@
       </p:sp>
       <p:sp>
         <p:nvSpPr>
-          <p:cNvPr id="36" name="Rounded Rectangle 35"/>
+          <p:cNvPr id="37" name="Rounded Rectangle 36"/>
           <p:cNvSpPr/>
           <p:nvPr/>
         </p:nvSpPr>
@@ -25711,7 +26443,7 @@
       </p:sp>
       <p:sp>
         <p:nvSpPr>
-          <p:cNvPr id="37" name="TextBox 36"/>
+          <p:cNvPr id="38" name="TextBox 37"/>
           <p:cNvSpPr txBox="1"/>
           <p:nvPr/>
         </p:nvSpPr>
@@ -25758,7 +26490,7 @@
       </p:sp>
       <p:sp>
         <p:nvSpPr>
-          <p:cNvPr id="38" name="Rounded Rectangle 37"/>
+          <p:cNvPr id="39" name="Rounded Rectangle 38"/>
           <p:cNvSpPr/>
           <p:nvPr/>
         </p:nvSpPr>
@@ -25896,9 +26628,33 @@
           </a:p>
         </p:txBody>
       </p:sp>
-      <p:sp>
-        <p:nvSpPr>
-          <p:cNvPr id="3" name="TextBox 2"/>
+      <p:pic>
+        <p:nvPicPr>
+          <p:cNvPr id="3" name="college-logo" descr="logo-mark.png"/>
+          <p:cNvPicPr>
+            <a:picLocks noChangeAspect="1"/>
+          </p:cNvPicPr>
+          <p:nvPr/>
+        </p:nvPicPr>
+        <p:blipFill>
+          <a:blip r:embed="rId2"/>
+          <a:stretch>
+            <a:fillRect/>
+          </a:stretch>
+        </p:blipFill>
+        <p:spPr>
+          <a:xfrm>
+            <a:off x="11203333" y="6199632"/>
+            <a:ext cx="275129" cy="310896"/>
+          </a:xfrm>
+          <a:prstGeom prst="rect">
+            <a:avLst/>
+          </a:prstGeom>
+        </p:spPr>
+      </p:pic>
+      <p:sp>
+        <p:nvSpPr>
+          <p:cNvPr id="4" name="TextBox 3"/>
           <p:cNvSpPr txBox="1"/>
           <p:nvPr/>
         </p:nvSpPr>
@@ -25967,13 +26723,13 @@
       </p:sp>
       <p:sp>
         <p:nvSpPr>
-          <p:cNvPr id="4" name="TextBox 3"/>
+          <p:cNvPr id="5" name="TextBox 4"/>
           <p:cNvSpPr txBox="1"/>
           <p:nvPr/>
         </p:nvSpPr>
         <p:spPr>
           <a:xfrm>
-            <a:off x="8826703" y="6272784"/>
+            <a:off x="8240677" y="6272784"/>
             <a:ext cx="2651760" cy="219456"/>
           </a:xfrm>
           <a:prstGeom prst="rect">
@@ -26036,7 +26792,7 @@
       </p:sp>
       <p:sp>
         <p:nvSpPr>
-          <p:cNvPr id="5" name="TextBox 4"/>
+          <p:cNvPr id="6" name="TextBox 5"/>
           <p:cNvSpPr txBox="1"/>
           <p:nvPr/>
         </p:nvSpPr>
@@ -26083,7 +26839,7 @@
       </p:sp>
       <p:sp>
         <p:nvSpPr>
-          <p:cNvPr id="6" name="TextBox 5"/>
+          <p:cNvPr id="7" name="TextBox 6"/>
           <p:cNvSpPr txBox="1"/>
           <p:nvPr/>
         </p:nvSpPr>
@@ -26130,7 +26886,7 @@
       </p:sp>
       <p:sp>
         <p:nvSpPr>
-          <p:cNvPr id="7" name="Rectangle 6"/>
+          <p:cNvPr id="8" name="Rectangle 7"/>
           <p:cNvSpPr/>
           <p:nvPr/>
         </p:nvSpPr>
@@ -26174,7 +26930,7 @@
       </p:sp>
       <p:sp>
         <p:nvSpPr>
-          <p:cNvPr id="8" name="TextBox 7"/>
+          <p:cNvPr id="9" name="TextBox 8"/>
           <p:cNvSpPr txBox="1"/>
           <p:nvPr/>
         </p:nvSpPr>
@@ -26221,7 +26977,7 @@
       </p:sp>
       <p:sp>
         <p:nvSpPr>
-          <p:cNvPr id="9" name="Rounded Rectangle 8"/>
+          <p:cNvPr id="10" name="Rounded Rectangle 9"/>
           <p:cNvSpPr/>
           <p:nvPr/>
         </p:nvSpPr>
@@ -26275,7 +27031,7 @@
       </p:sp>
       <p:sp>
         <p:nvSpPr>
-          <p:cNvPr id="10" name="Rectangle 9"/>
+          <p:cNvPr id="11" name="Rectangle 10"/>
           <p:cNvSpPr/>
           <p:nvPr/>
         </p:nvSpPr>
@@ -26319,7 +27075,7 @@
       </p:sp>
       <p:sp>
         <p:nvSpPr>
-          <p:cNvPr id="11" name="TextBox 10"/>
+          <p:cNvPr id="12" name="TextBox 11"/>
           <p:cNvSpPr txBox="1"/>
           <p:nvPr/>
         </p:nvSpPr>
@@ -26366,7 +27122,7 @@
       </p:sp>
       <p:sp>
         <p:nvSpPr>
-          <p:cNvPr id="12" name="TextBox 11"/>
+          <p:cNvPr id="13" name="TextBox 12"/>
           <p:cNvSpPr txBox="1"/>
           <p:nvPr/>
         </p:nvSpPr>
@@ -26413,7 +27169,7 @@
       </p:sp>
       <p:sp>
         <p:nvSpPr>
-          <p:cNvPr id="13" name="Rounded Rectangle 12"/>
+          <p:cNvPr id="14" name="Rounded Rectangle 13"/>
           <p:cNvSpPr/>
           <p:nvPr/>
         </p:nvSpPr>
@@ -26467,7 +27223,7 @@
       </p:sp>
       <p:sp>
         <p:nvSpPr>
-          <p:cNvPr id="14" name="Rectangle 13"/>
+          <p:cNvPr id="15" name="Rectangle 14"/>
           <p:cNvSpPr/>
           <p:nvPr/>
         </p:nvSpPr>
@@ -26511,7 +27267,7 @@
       </p:sp>
       <p:sp>
         <p:nvSpPr>
-          <p:cNvPr id="15" name="TextBox 14"/>
+          <p:cNvPr id="16" name="TextBox 15"/>
           <p:cNvSpPr txBox="1"/>
           <p:nvPr/>
         </p:nvSpPr>
@@ -26558,7 +27314,7 @@
       </p:sp>
       <p:sp>
         <p:nvSpPr>
-          <p:cNvPr id="16" name="TextBox 15"/>
+          <p:cNvPr id="17" name="TextBox 16"/>
           <p:cNvSpPr txBox="1"/>
           <p:nvPr/>
         </p:nvSpPr>
@@ -26605,7 +27361,7 @@
       </p:sp>
       <p:sp>
         <p:nvSpPr>
-          <p:cNvPr id="17" name="Rounded Rectangle 16"/>
+          <p:cNvPr id="18" name="Rounded Rectangle 17"/>
           <p:cNvSpPr/>
           <p:nvPr/>
         </p:nvSpPr>
@@ -26659,7 +27415,7 @@
       </p:sp>
       <p:sp>
         <p:nvSpPr>
-          <p:cNvPr id="18" name="Rectangle 17"/>
+          <p:cNvPr id="19" name="Rectangle 18"/>
           <p:cNvSpPr/>
           <p:nvPr/>
         </p:nvSpPr>
@@ -26703,7 +27459,7 @@
       </p:sp>
       <p:sp>
         <p:nvSpPr>
-          <p:cNvPr id="19" name="TextBox 18"/>
+          <p:cNvPr id="20" name="TextBox 19"/>
           <p:cNvSpPr txBox="1"/>
           <p:nvPr/>
         </p:nvSpPr>
@@ -26750,7 +27506,7 @@
       </p:sp>
       <p:sp>
         <p:nvSpPr>
-          <p:cNvPr id="20" name="TextBox 19"/>
+          <p:cNvPr id="21" name="TextBox 20"/>
           <p:cNvSpPr txBox="1"/>
           <p:nvPr/>
         </p:nvSpPr>
@@ -26797,7 +27553,7 @@
       </p:sp>
       <p:sp>
         <p:nvSpPr>
-          <p:cNvPr id="21" name="Rounded Rectangle 20"/>
+          <p:cNvPr id="22" name="Rounded Rectangle 21"/>
           <p:cNvSpPr/>
           <p:nvPr/>
         </p:nvSpPr>
@@ -26851,7 +27607,7 @@
       </p:sp>
       <p:sp>
         <p:nvSpPr>
-          <p:cNvPr id="22" name="Rectangle 21"/>
+          <p:cNvPr id="23" name="Rectangle 22"/>
           <p:cNvSpPr/>
           <p:nvPr/>
         </p:nvSpPr>
@@ -26895,7 +27651,7 @@
       </p:sp>
       <p:sp>
         <p:nvSpPr>
-          <p:cNvPr id="23" name="TextBox 22"/>
+          <p:cNvPr id="24" name="TextBox 23"/>
           <p:cNvSpPr txBox="1"/>
           <p:nvPr/>
         </p:nvSpPr>
@@ -26942,7 +27698,7 @@
       </p:sp>
       <p:sp>
         <p:nvSpPr>
-          <p:cNvPr id="24" name="TextBox 23"/>
+          <p:cNvPr id="25" name="TextBox 24"/>
           <p:cNvSpPr txBox="1"/>
           <p:nvPr/>
         </p:nvSpPr>
@@ -27049,9 +27805,33 @@
           </a:p>
         </p:txBody>
       </p:sp>
-      <p:sp>
-        <p:nvSpPr>
-          <p:cNvPr id="3" name="TextBox 2"/>
+      <p:pic>
+        <p:nvPicPr>
+          <p:cNvPr id="3" name="college-logo" descr="logo-mark.png"/>
+          <p:cNvPicPr>
+            <a:picLocks noChangeAspect="1"/>
+          </p:cNvPicPr>
+          <p:nvPr/>
+        </p:nvPicPr>
+        <p:blipFill>
+          <a:blip r:embed="rId2"/>
+          <a:stretch>
+            <a:fillRect/>
+          </a:stretch>
+        </p:blipFill>
+        <p:spPr>
+          <a:xfrm>
+            <a:off x="11203333" y="6199632"/>
+            <a:ext cx="275129" cy="310896"/>
+          </a:xfrm>
+          <a:prstGeom prst="rect">
+            <a:avLst/>
+          </a:prstGeom>
+        </p:spPr>
+      </p:pic>
+      <p:sp>
+        <p:nvSpPr>
+          <p:cNvPr id="4" name="TextBox 3"/>
           <p:cNvSpPr txBox="1"/>
           <p:nvPr/>
         </p:nvSpPr>
@@ -27120,13 +27900,13 @@
       </p:sp>
       <p:sp>
         <p:nvSpPr>
-          <p:cNvPr id="4" name="TextBox 3"/>
+          <p:cNvPr id="5" name="TextBox 4"/>
           <p:cNvSpPr txBox="1"/>
           <p:nvPr/>
         </p:nvSpPr>
         <p:spPr>
           <a:xfrm>
-            <a:off x="8826703" y="6272784"/>
+            <a:off x="8240677" y="6272784"/>
             <a:ext cx="2651760" cy="219456"/>
           </a:xfrm>
           <a:prstGeom prst="rect">
@@ -27189,7 +27969,7 @@
       </p:sp>
       <p:sp>
         <p:nvSpPr>
-          <p:cNvPr id="5" name="TextBox 4"/>
+          <p:cNvPr id="6" name="TextBox 5"/>
           <p:cNvSpPr txBox="1"/>
           <p:nvPr/>
         </p:nvSpPr>
@@ -27236,7 +28016,7 @@
       </p:sp>
       <p:sp>
         <p:nvSpPr>
-          <p:cNvPr id="6" name="TextBox 5"/>
+          <p:cNvPr id="7" name="TextBox 6"/>
           <p:cNvSpPr txBox="1"/>
           <p:nvPr/>
         </p:nvSpPr>
@@ -27283,7 +28063,7 @@
       </p:sp>
       <p:sp>
         <p:nvSpPr>
-          <p:cNvPr id="7" name="Rectangle 6"/>
+          <p:cNvPr id="8" name="Rectangle 7"/>
           <p:cNvSpPr/>
           <p:nvPr/>
         </p:nvSpPr>
@@ -27327,7 +28107,7 @@
       </p:sp>
       <p:sp>
         <p:nvSpPr>
-          <p:cNvPr id="8" name="TextBox 7"/>
+          <p:cNvPr id="9" name="TextBox 8"/>
           <p:cNvSpPr txBox="1"/>
           <p:nvPr/>
         </p:nvSpPr>
@@ -27374,7 +28154,7 @@
       </p:sp>
       <p:sp>
         <p:nvSpPr>
-          <p:cNvPr id="9" name="Rounded Rectangle 8"/>
+          <p:cNvPr id="10" name="Rounded Rectangle 9"/>
           <p:cNvSpPr/>
           <p:nvPr/>
         </p:nvSpPr>
@@ -27428,7 +28208,7 @@
       </p:sp>
       <p:sp>
         <p:nvSpPr>
-          <p:cNvPr id="10" name="Rectangle 9"/>
+          <p:cNvPr id="11" name="Rectangle 10"/>
           <p:cNvSpPr/>
           <p:nvPr/>
         </p:nvSpPr>
@@ -27472,7 +28252,7 @@
       </p:sp>
       <p:sp>
         <p:nvSpPr>
-          <p:cNvPr id="11" name="Oval 10"/>
+          <p:cNvPr id="12" name="Oval 11"/>
           <p:cNvSpPr/>
           <p:nvPr/>
         </p:nvSpPr>
@@ -27516,7 +28296,7 @@
       </p:sp>
       <p:sp>
         <p:nvSpPr>
-          <p:cNvPr id="12" name="TextBox 11"/>
+          <p:cNvPr id="13" name="TextBox 12"/>
           <p:cNvSpPr txBox="1"/>
           <p:nvPr/>
         </p:nvSpPr>
@@ -27563,7 +28343,7 @@
       </p:sp>
       <p:sp>
         <p:nvSpPr>
-          <p:cNvPr id="13" name="TextBox 12"/>
+          <p:cNvPr id="14" name="TextBox 13"/>
           <p:cNvSpPr txBox="1"/>
           <p:nvPr/>
         </p:nvSpPr>
@@ -27610,7 +28390,7 @@
       </p:sp>
       <p:sp>
         <p:nvSpPr>
-          <p:cNvPr id="14" name="TextBox 13"/>
+          <p:cNvPr id="15" name="TextBox 14"/>
           <p:cNvSpPr txBox="1"/>
           <p:nvPr/>
         </p:nvSpPr>
@@ -27657,7 +28437,7 @@
       </p:sp>
       <p:sp>
         <p:nvSpPr>
-          <p:cNvPr id="15" name="Rounded Rectangle 14"/>
+          <p:cNvPr id="16" name="Rounded Rectangle 15"/>
           <p:cNvSpPr/>
           <p:nvPr/>
         </p:nvSpPr>
@@ -27711,7 +28491,7 @@
       </p:sp>
       <p:sp>
         <p:nvSpPr>
-          <p:cNvPr id="16" name="Rectangle 15"/>
+          <p:cNvPr id="17" name="Rectangle 16"/>
           <p:cNvSpPr/>
           <p:nvPr/>
         </p:nvSpPr>
@@ -27755,7 +28535,7 @@
       </p:sp>
       <p:sp>
         <p:nvSpPr>
-          <p:cNvPr id="17" name="Oval 16"/>
+          <p:cNvPr id="18" name="Oval 17"/>
           <p:cNvSpPr/>
           <p:nvPr/>
         </p:nvSpPr>
@@ -27799,7 +28579,7 @@
       </p:sp>
       <p:sp>
         <p:nvSpPr>
-          <p:cNvPr id="18" name="TextBox 17"/>
+          <p:cNvPr id="19" name="TextBox 18"/>
           <p:cNvSpPr txBox="1"/>
           <p:nvPr/>
         </p:nvSpPr>
@@ -27846,7 +28626,7 @@
       </p:sp>
       <p:sp>
         <p:nvSpPr>
-          <p:cNvPr id="19" name="TextBox 18"/>
+          <p:cNvPr id="20" name="TextBox 19"/>
           <p:cNvSpPr txBox="1"/>
           <p:nvPr/>
         </p:nvSpPr>
@@ -27893,7 +28673,7 @@
       </p:sp>
       <p:sp>
         <p:nvSpPr>
-          <p:cNvPr id="20" name="TextBox 19"/>
+          <p:cNvPr id="21" name="TextBox 20"/>
           <p:cNvSpPr txBox="1"/>
           <p:nvPr/>
         </p:nvSpPr>
@@ -27940,7 +28720,7 @@
       </p:sp>
       <p:sp>
         <p:nvSpPr>
-          <p:cNvPr id="21" name="Rounded Rectangle 20"/>
+          <p:cNvPr id="22" name="Rounded Rectangle 21"/>
           <p:cNvSpPr/>
           <p:nvPr/>
         </p:nvSpPr>
@@ -27994,7 +28774,7 @@
       </p:sp>
       <p:sp>
         <p:nvSpPr>
-          <p:cNvPr id="22" name="Rectangle 21"/>
+          <p:cNvPr id="23" name="Rectangle 22"/>
           <p:cNvSpPr/>
           <p:nvPr/>
         </p:nvSpPr>
@@ -28038,7 +28818,7 @@
       </p:sp>
       <p:sp>
         <p:nvSpPr>
-          <p:cNvPr id="23" name="Oval 22"/>
+          <p:cNvPr id="24" name="Oval 23"/>
           <p:cNvSpPr/>
           <p:nvPr/>
         </p:nvSpPr>
@@ -28082,7 +28862,7 @@
       </p:sp>
       <p:sp>
         <p:nvSpPr>
-          <p:cNvPr id="24" name="TextBox 23"/>
+          <p:cNvPr id="25" name="TextBox 24"/>
           <p:cNvSpPr txBox="1"/>
           <p:nvPr/>
         </p:nvSpPr>
@@ -28129,7 +28909,7 @@
       </p:sp>
       <p:sp>
         <p:nvSpPr>
-          <p:cNvPr id="25" name="TextBox 24"/>
+          <p:cNvPr id="26" name="TextBox 25"/>
           <p:cNvSpPr txBox="1"/>
           <p:nvPr/>
         </p:nvSpPr>
@@ -28176,7 +28956,7 @@
       </p:sp>
       <p:sp>
         <p:nvSpPr>
-          <p:cNvPr id="26" name="TextBox 25"/>
+          <p:cNvPr id="27" name="TextBox 26"/>
           <p:cNvSpPr txBox="1"/>
           <p:nvPr/>
         </p:nvSpPr>
@@ -28659,6 +29439,76 @@
           </a:p>
         </p:txBody>
       </p:sp>
+      <p:sp>
+        <p:nvSpPr>
+          <p:cNvPr id="11" name="logo-plate"/>
+          <p:cNvSpPr/>
+          <p:nvPr/>
+        </p:nvSpPr>
+        <p:spPr>
+          <a:xfrm>
+            <a:off x="9512190" y="539496"/>
+            <a:ext cx="1993704" cy="987552"/>
+          </a:xfrm>
+          <a:prstGeom prst="roundRect">
+            <a:avLst>
+              <a:gd name="adj" fmla="val 14000"/>
+            </a:avLst>
+          </a:prstGeom>
+          <a:solidFill>
+            <a:srgbClr val="FFFFFF"/>
+          </a:solidFill>
+          <a:ln>
+            <a:noFill/>
+          </a:ln>
+          <a:effectLst/>
+        </p:spPr>
+        <p:style>
+          <a:lnRef idx="1">
+            <a:schemeClr val="accent1"/>
+          </a:lnRef>
+          <a:fillRef idx="3">
+            <a:schemeClr val="accent1"/>
+          </a:fillRef>
+          <a:effectRef idx="2">
+            <a:schemeClr val="accent1"/>
+          </a:effectRef>
+          <a:fontRef idx="minor">
+            <a:schemeClr val="lt1"/>
+          </a:fontRef>
+        </p:style>
+        <p:txBody>
+          <a:bodyPr rtlCol="0" anchor="ctr" wrap="square"/>
+          <a:lstStyle/>
+          <a:p>
+            <a:pPr algn="ctr"/>
+          </a:p>
+        </p:txBody>
+      </p:sp>
+      <p:pic>
+        <p:nvPicPr>
+          <p:cNvPr id="12" name="college-logo" descr="logo-full.png"/>
+          <p:cNvPicPr>
+            <a:picLocks noChangeAspect="1"/>
+          </p:cNvPicPr>
+          <p:nvPr/>
+        </p:nvPicPr>
+        <p:blipFill>
+          <a:blip r:embed="rId2"/>
+          <a:stretch>
+            <a:fillRect/>
+          </a:stretch>
+        </p:blipFill>
+        <p:spPr>
+          <a:xfrm>
+            <a:off x="9631062" y="658368"/>
+            <a:ext cx="1755961" cy="749808"/>
+          </a:xfrm>
+          <a:prstGeom prst="rect">
+            <a:avLst/>
+          </a:prstGeom>
+        </p:spPr>
+      </p:pic>
     </p:spTree>
   </p:cSld>
   <p:clrMapOvr>
@@ -28721,9 +29571,33 @@
           </a:p>
         </p:txBody>
       </p:sp>
-      <p:sp>
-        <p:nvSpPr>
-          <p:cNvPr id="3" name="TextBox 2"/>
+      <p:pic>
+        <p:nvPicPr>
+          <p:cNvPr id="3" name="college-logo" descr="logo-mark.png"/>
+          <p:cNvPicPr>
+            <a:picLocks noChangeAspect="1"/>
+          </p:cNvPicPr>
+          <p:nvPr/>
+        </p:nvPicPr>
+        <p:blipFill>
+          <a:blip r:embed="rId2"/>
+          <a:stretch>
+            <a:fillRect/>
+          </a:stretch>
+        </p:blipFill>
+        <p:spPr>
+          <a:xfrm>
+            <a:off x="11203333" y="6199632"/>
+            <a:ext cx="275129" cy="310896"/>
+          </a:xfrm>
+          <a:prstGeom prst="rect">
+            <a:avLst/>
+          </a:prstGeom>
+        </p:spPr>
+      </p:pic>
+      <p:sp>
+        <p:nvSpPr>
+          <p:cNvPr id="4" name="TextBox 3"/>
           <p:cNvSpPr txBox="1"/>
           <p:nvPr/>
         </p:nvSpPr>
@@ -28792,13 +29666,13 @@
       </p:sp>
       <p:sp>
         <p:nvSpPr>
-          <p:cNvPr id="4" name="TextBox 3"/>
+          <p:cNvPr id="5" name="TextBox 4"/>
           <p:cNvSpPr txBox="1"/>
           <p:nvPr/>
         </p:nvSpPr>
         <p:spPr>
           <a:xfrm>
-            <a:off x="8826703" y="6272784"/>
+            <a:off x="8240677" y="6272784"/>
             <a:ext cx="2651760" cy="219456"/>
           </a:xfrm>
           <a:prstGeom prst="rect">
@@ -28861,7 +29735,7 @@
       </p:sp>
       <p:sp>
         <p:nvSpPr>
-          <p:cNvPr id="5" name="TextBox 4"/>
+          <p:cNvPr id="6" name="TextBox 5"/>
           <p:cNvSpPr txBox="1"/>
           <p:nvPr/>
         </p:nvSpPr>
@@ -28908,7 +29782,7 @@
       </p:sp>
       <p:sp>
         <p:nvSpPr>
-          <p:cNvPr id="6" name="TextBox 5"/>
+          <p:cNvPr id="7" name="TextBox 6"/>
           <p:cNvSpPr txBox="1"/>
           <p:nvPr/>
         </p:nvSpPr>
@@ -28955,7 +29829,7 @@
       </p:sp>
       <p:sp>
         <p:nvSpPr>
-          <p:cNvPr id="7" name="Rectangle 6"/>
+          <p:cNvPr id="8" name="Rectangle 7"/>
           <p:cNvSpPr/>
           <p:nvPr/>
         </p:nvSpPr>
@@ -28999,7 +29873,7 @@
       </p:sp>
       <p:sp>
         <p:nvSpPr>
-          <p:cNvPr id="8" name="Rectangle 7"/>
+          <p:cNvPr id="9" name="Rectangle 8"/>
           <p:cNvSpPr/>
           <p:nvPr/>
         </p:nvSpPr>
@@ -29043,7 +29917,7 @@
       </p:sp>
       <p:sp>
         <p:nvSpPr>
-          <p:cNvPr id="9" name="Oval 8"/>
+          <p:cNvPr id="10" name="Oval 9"/>
           <p:cNvSpPr/>
           <p:nvPr/>
         </p:nvSpPr>
@@ -29087,7 +29961,7 @@
       </p:sp>
       <p:sp>
         <p:nvSpPr>
-          <p:cNvPr id="10" name="TextBox 9"/>
+          <p:cNvPr id="11" name="TextBox 10"/>
           <p:cNvSpPr txBox="1"/>
           <p:nvPr/>
         </p:nvSpPr>
@@ -29134,7 +30008,7 @@
       </p:sp>
       <p:sp>
         <p:nvSpPr>
-          <p:cNvPr id="11" name="Rounded Rectangle 10"/>
+          <p:cNvPr id="12" name="Rounded Rectangle 11"/>
           <p:cNvSpPr/>
           <p:nvPr/>
         </p:nvSpPr>
@@ -29182,7 +30056,7 @@
       </p:sp>
       <p:sp>
         <p:nvSpPr>
-          <p:cNvPr id="12" name="TextBox 11"/>
+          <p:cNvPr id="13" name="TextBox 12"/>
           <p:cNvSpPr txBox="1"/>
           <p:nvPr/>
         </p:nvSpPr>
@@ -29229,7 +30103,7 @@
       </p:sp>
       <p:sp>
         <p:nvSpPr>
-          <p:cNvPr id="13" name="TextBox 12"/>
+          <p:cNvPr id="14" name="TextBox 13"/>
           <p:cNvSpPr txBox="1"/>
           <p:nvPr/>
         </p:nvSpPr>
@@ -29276,7 +30150,7 @@
       </p:sp>
       <p:sp>
         <p:nvSpPr>
-          <p:cNvPr id="14" name="Oval 13"/>
+          <p:cNvPr id="15" name="Oval 14"/>
           <p:cNvSpPr/>
           <p:nvPr/>
         </p:nvSpPr>
@@ -29320,7 +30194,7 @@
       </p:sp>
       <p:sp>
         <p:nvSpPr>
-          <p:cNvPr id="15" name="TextBox 14"/>
+          <p:cNvPr id="16" name="TextBox 15"/>
           <p:cNvSpPr txBox="1"/>
           <p:nvPr/>
         </p:nvSpPr>
@@ -29367,7 +30241,7 @@
       </p:sp>
       <p:sp>
         <p:nvSpPr>
-          <p:cNvPr id="16" name="Rounded Rectangle 15"/>
+          <p:cNvPr id="17" name="Rounded Rectangle 16"/>
           <p:cNvSpPr/>
           <p:nvPr/>
         </p:nvSpPr>
@@ -29415,7 +30289,7 @@
       </p:sp>
       <p:sp>
         <p:nvSpPr>
-          <p:cNvPr id="17" name="TextBox 16"/>
+          <p:cNvPr id="18" name="TextBox 17"/>
           <p:cNvSpPr txBox="1"/>
           <p:nvPr/>
         </p:nvSpPr>
@@ -29462,7 +30336,7 @@
       </p:sp>
       <p:sp>
         <p:nvSpPr>
-          <p:cNvPr id="18" name="TextBox 17"/>
+          <p:cNvPr id="19" name="TextBox 18"/>
           <p:cNvSpPr txBox="1"/>
           <p:nvPr/>
         </p:nvSpPr>
@@ -29509,7 +30383,7 @@
       </p:sp>
       <p:sp>
         <p:nvSpPr>
-          <p:cNvPr id="19" name="Oval 18"/>
+          <p:cNvPr id="20" name="Oval 19"/>
           <p:cNvSpPr/>
           <p:nvPr/>
         </p:nvSpPr>
@@ -29553,7 +30427,7 @@
       </p:sp>
       <p:sp>
         <p:nvSpPr>
-          <p:cNvPr id="20" name="TextBox 19"/>
+          <p:cNvPr id="21" name="TextBox 20"/>
           <p:cNvSpPr txBox="1"/>
           <p:nvPr/>
         </p:nvSpPr>
@@ -29600,7 +30474,7 @@
       </p:sp>
       <p:sp>
         <p:nvSpPr>
-          <p:cNvPr id="21" name="Rounded Rectangle 20"/>
+          <p:cNvPr id="22" name="Rounded Rectangle 21"/>
           <p:cNvSpPr/>
           <p:nvPr/>
         </p:nvSpPr>
@@ -29648,7 +30522,7 @@
       </p:sp>
       <p:sp>
         <p:nvSpPr>
-          <p:cNvPr id="22" name="TextBox 21"/>
+          <p:cNvPr id="23" name="TextBox 22"/>
           <p:cNvSpPr txBox="1"/>
           <p:nvPr/>
         </p:nvSpPr>
@@ -29695,7 +30569,7 @@
       </p:sp>
       <p:sp>
         <p:nvSpPr>
-          <p:cNvPr id="23" name="TextBox 22"/>
+          <p:cNvPr id="24" name="TextBox 23"/>
           <p:cNvSpPr txBox="1"/>
           <p:nvPr/>
         </p:nvSpPr>
@@ -29742,7 +30616,7 @@
       </p:sp>
       <p:sp>
         <p:nvSpPr>
-          <p:cNvPr id="24" name="Oval 23"/>
+          <p:cNvPr id="25" name="Oval 24"/>
           <p:cNvSpPr/>
           <p:nvPr/>
         </p:nvSpPr>
@@ -29786,7 +30660,7 @@
       </p:sp>
       <p:sp>
         <p:nvSpPr>
-          <p:cNvPr id="25" name="TextBox 24"/>
+          <p:cNvPr id="26" name="TextBox 25"/>
           <p:cNvSpPr txBox="1"/>
           <p:nvPr/>
         </p:nvSpPr>
@@ -29833,7 +30707,7 @@
       </p:sp>
       <p:sp>
         <p:nvSpPr>
-          <p:cNvPr id="26" name="Rounded Rectangle 25"/>
+          <p:cNvPr id="27" name="Rounded Rectangle 26"/>
           <p:cNvSpPr/>
           <p:nvPr/>
         </p:nvSpPr>
@@ -29881,7 +30755,7 @@
       </p:sp>
       <p:sp>
         <p:nvSpPr>
-          <p:cNvPr id="27" name="TextBox 26"/>
+          <p:cNvPr id="28" name="TextBox 27"/>
           <p:cNvSpPr txBox="1"/>
           <p:nvPr/>
         </p:nvSpPr>
@@ -29928,7 +30802,7 @@
       </p:sp>
       <p:sp>
         <p:nvSpPr>
-          <p:cNvPr id="28" name="TextBox 27"/>
+          <p:cNvPr id="29" name="TextBox 28"/>
           <p:cNvSpPr txBox="1"/>
           <p:nvPr/>
         </p:nvSpPr>
@@ -29975,7 +30849,7 @@
       </p:sp>
       <p:sp>
         <p:nvSpPr>
-          <p:cNvPr id="29" name="Oval 28"/>
+          <p:cNvPr id="30" name="Oval 29"/>
           <p:cNvSpPr/>
           <p:nvPr/>
         </p:nvSpPr>
@@ -30019,7 +30893,7 @@
       </p:sp>
       <p:sp>
         <p:nvSpPr>
-          <p:cNvPr id="30" name="TextBox 29"/>
+          <p:cNvPr id="31" name="TextBox 30"/>
           <p:cNvSpPr txBox="1"/>
           <p:nvPr/>
         </p:nvSpPr>
@@ -30066,7 +30940,7 @@
       </p:sp>
       <p:sp>
         <p:nvSpPr>
-          <p:cNvPr id="31" name="Rounded Rectangle 30"/>
+          <p:cNvPr id="32" name="Rounded Rectangle 31"/>
           <p:cNvSpPr/>
           <p:nvPr/>
         </p:nvSpPr>
@@ -30114,7 +30988,7 @@
       </p:sp>
       <p:sp>
         <p:nvSpPr>
-          <p:cNvPr id="32" name="TextBox 31"/>
+          <p:cNvPr id="33" name="TextBox 32"/>
           <p:cNvSpPr txBox="1"/>
           <p:nvPr/>
         </p:nvSpPr>
@@ -30161,7 +31035,7 @@
       </p:sp>
       <p:sp>
         <p:nvSpPr>
-          <p:cNvPr id="33" name="TextBox 32"/>
+          <p:cNvPr id="34" name="TextBox 33"/>
           <p:cNvSpPr txBox="1"/>
           <p:nvPr/>
         </p:nvSpPr>
@@ -30208,7 +31082,7 @@
       </p:sp>
       <p:sp>
         <p:nvSpPr>
-          <p:cNvPr id="34" name="Oval 33"/>
+          <p:cNvPr id="35" name="Oval 34"/>
           <p:cNvSpPr/>
           <p:nvPr/>
         </p:nvSpPr>
@@ -30252,7 +31126,7 @@
       </p:sp>
       <p:sp>
         <p:nvSpPr>
-          <p:cNvPr id="35" name="TextBox 34"/>
+          <p:cNvPr id="36" name="TextBox 35"/>
           <p:cNvSpPr txBox="1"/>
           <p:nvPr/>
         </p:nvSpPr>
@@ -30299,7 +31173,7 @@
       </p:sp>
       <p:sp>
         <p:nvSpPr>
-          <p:cNvPr id="36" name="Rounded Rectangle 35"/>
+          <p:cNvPr id="37" name="Rounded Rectangle 36"/>
           <p:cNvSpPr/>
           <p:nvPr/>
         </p:nvSpPr>
@@ -30347,7 +31221,7 @@
       </p:sp>
       <p:sp>
         <p:nvSpPr>
-          <p:cNvPr id="37" name="TextBox 36"/>
+          <p:cNvPr id="38" name="TextBox 37"/>
           <p:cNvSpPr txBox="1"/>
           <p:nvPr/>
         </p:nvSpPr>
@@ -30394,7 +31268,7 @@
       </p:sp>
       <p:sp>
         <p:nvSpPr>
-          <p:cNvPr id="38" name="TextBox 37"/>
+          <p:cNvPr id="39" name="TextBox 38"/>
           <p:cNvSpPr txBox="1"/>
           <p:nvPr/>
         </p:nvSpPr>
@@ -30441,7 +31315,7 @@
       </p:sp>
       <p:sp>
         <p:nvSpPr>
-          <p:cNvPr id="39" name="Rounded Rectangle 38"/>
+          <p:cNvPr id="40" name="Rounded Rectangle 39"/>
           <p:cNvSpPr/>
           <p:nvPr/>
         </p:nvSpPr>
@@ -30508,7 +31382,7 @@
       </p:sp>
       <p:sp>
         <p:nvSpPr>
-          <p:cNvPr id="40" name="Rectangle 39"/>
+          <p:cNvPr id="41" name="Rectangle 40"/>
           <p:cNvSpPr/>
           <p:nvPr/>
         </p:nvSpPr>

</xml_diff>